<commit_message>
Detalles en el Sistema y Power y Word
</commit_message>
<xml_diff>
--- a/DOC/Presentacion de Tesis Dariel Cabrera Lopez.pptx
+++ b/DOC/Presentacion de Tesis Dariel Cabrera Lopez.pptx
@@ -5,7 +5,7 @@
     <p:sldMasterId id="2147483648" r:id="rId1"/>
   </p:sldMasterIdLst>
   <p:notesMasterIdLst>
-    <p:notesMasterId r:id="rId23"/>
+    <p:notesMasterId r:id="rId28"/>
   </p:notesMasterIdLst>
   <p:sldIdLst>
     <p:sldId id="257" r:id="rId2"/>
@@ -24,11 +24,16 @@
     <p:sldId id="328" r:id="rId15"/>
     <p:sldId id="324" r:id="rId16"/>
     <p:sldId id="329" r:id="rId17"/>
-    <p:sldId id="331" r:id="rId18"/>
-    <p:sldId id="330" r:id="rId19"/>
-    <p:sldId id="332" r:id="rId20"/>
-    <p:sldId id="333" r:id="rId21"/>
-    <p:sldId id="334" r:id="rId22"/>
+    <p:sldId id="338" r:id="rId18"/>
+    <p:sldId id="340" r:id="rId19"/>
+    <p:sldId id="339" r:id="rId20"/>
+    <p:sldId id="331" r:id="rId21"/>
+    <p:sldId id="330" r:id="rId22"/>
+    <p:sldId id="332" r:id="rId23"/>
+    <p:sldId id="341" r:id="rId24"/>
+    <p:sldId id="333" r:id="rId25"/>
+    <p:sldId id="334" r:id="rId26"/>
+    <p:sldId id="342" r:id="rId27"/>
   </p:sldIdLst>
   <p:sldSz cx="9144000" cy="6858000" type="screen4x3"/>
   <p:notesSz cx="6858000" cy="9144000"/>
@@ -3233,7 +3238,7 @@
           <a:p>
             <a:fld id="{64803A06-23BD-4449-A1D1-6ADBCF91F056}" type="datetimeFigureOut">
               <a:rPr lang="es-ES_tradnl" smtClean="0"/>
-              <a:t>02/06/2025</a:t>
+              <a:t>04/06/2025</a:t>
             </a:fld>
             <a:endParaRPr lang="es-ES_tradnl"/>
           </a:p>
@@ -3764,7 +3769,7 @@
           <a:p>
             <a:fld id="{98963F9C-36B4-4ECD-BECC-604E57EA70AC}" type="datetime1">
               <a:rPr lang="es-ES" smtClean="0"/>
-              <a:t>02/06/2025</a:t>
+              <a:t>04/06/2025</a:t>
             </a:fld>
             <a:endParaRPr lang="es-ES"/>
           </a:p>
@@ -3927,7 +3932,7 @@
           <a:p>
             <a:fld id="{C72EFBCE-E3F3-42E3-AA42-D22E0C63B5E5}" type="datetime1">
               <a:rPr lang="es-ES" smtClean="0"/>
-              <a:t>02/06/2025</a:t>
+              <a:t>04/06/2025</a:t>
             </a:fld>
             <a:endParaRPr lang="es-ES"/>
           </a:p>
@@ -4100,7 +4105,7 @@
           <a:p>
             <a:fld id="{8569FFDC-06D8-42F3-B15A-134344304A07}" type="datetime1">
               <a:rPr lang="es-ES" smtClean="0"/>
-              <a:t>02/06/2025</a:t>
+              <a:t>04/06/2025</a:t>
             </a:fld>
             <a:endParaRPr lang="es-ES"/>
           </a:p>
@@ -4263,7 +4268,7 @@
           <a:p>
             <a:fld id="{2B3D0996-3F59-44A3-A62A-DD95A94764C7}" type="datetime1">
               <a:rPr lang="es-ES" smtClean="0"/>
-              <a:t>02/06/2025</a:t>
+              <a:t>04/06/2025</a:t>
             </a:fld>
             <a:endParaRPr lang="es-ES"/>
           </a:p>
@@ -4503,7 +4508,7 @@
           <a:p>
             <a:fld id="{52120030-6113-4ABE-B7D6-521760BB2F2A}" type="datetime1">
               <a:rPr lang="es-ES" smtClean="0"/>
-              <a:t>02/06/2025</a:t>
+              <a:t>04/06/2025</a:t>
             </a:fld>
             <a:endParaRPr lang="es-ES"/>
           </a:p>
@@ -4783,7 +4788,7 @@
           <a:p>
             <a:fld id="{A8AD0488-9BF8-4343-A7C8-334439AC023A}" type="datetime1">
               <a:rPr lang="es-ES" smtClean="0"/>
-              <a:t>02/06/2025</a:t>
+              <a:t>04/06/2025</a:t>
             </a:fld>
             <a:endParaRPr lang="es-ES"/>
           </a:p>
@@ -5197,7 +5202,7 @@
           <a:p>
             <a:fld id="{B91DCCD4-540D-42E8-A1D5-532A6F28BA54}" type="datetime1">
               <a:rPr lang="es-ES" smtClean="0"/>
-              <a:t>02/06/2025</a:t>
+              <a:t>04/06/2025</a:t>
             </a:fld>
             <a:endParaRPr lang="es-ES"/>
           </a:p>
@@ -5309,7 +5314,7 @@
           <a:p>
             <a:fld id="{7EFCCA53-11C7-4627-936A-79881176CA9F}" type="datetime1">
               <a:rPr lang="es-ES" smtClean="0"/>
-              <a:t>02/06/2025</a:t>
+              <a:t>04/06/2025</a:t>
             </a:fld>
             <a:endParaRPr lang="es-ES"/>
           </a:p>
@@ -5399,7 +5404,7 @@
           <a:p>
             <a:fld id="{5DAFE5E1-20AD-4F66-9853-038A786E08A1}" type="datetime1">
               <a:rPr lang="es-ES" smtClean="0"/>
-              <a:t>02/06/2025</a:t>
+              <a:t>04/06/2025</a:t>
             </a:fld>
             <a:endParaRPr lang="es-ES"/>
           </a:p>
@@ -5669,7 +5674,7 @@
           <a:p>
             <a:fld id="{F3470BC8-43CE-409A-BE0C-FBE54D4B7D7F}" type="datetime1">
               <a:rPr lang="es-ES" smtClean="0"/>
-              <a:t>02/06/2025</a:t>
+              <a:t>04/06/2025</a:t>
             </a:fld>
             <a:endParaRPr lang="es-ES"/>
           </a:p>
@@ -5916,7 +5921,7 @@
           <a:p>
             <a:fld id="{4A0853D2-8CEB-49C0-B2DA-82EEA4C831AA}" type="datetime1">
               <a:rPr lang="es-ES" smtClean="0"/>
-              <a:t>02/06/2025</a:t>
+              <a:t>04/06/2025</a:t>
             </a:fld>
             <a:endParaRPr lang="es-ES"/>
           </a:p>
@@ -6122,7 +6127,7 @@
           <a:p>
             <a:fld id="{E055BF71-A5A3-4F60-820F-A4D41CCBAC58}" type="datetime1">
               <a:rPr lang="es-ES" smtClean="0"/>
-              <a:t>02/06/2025</a:t>
+              <a:t>04/06/2025</a:t>
             </a:fld>
             <a:endParaRPr lang="es-ES"/>
           </a:p>
@@ -8912,19 +8917,6 @@
               <a:t>Las historias técnicas o “Requisitos no funcionales” propiedades o cualidades que el producto debe tener.</a:t>
             </a:r>
           </a:p>
-          <a:p>
-            <a:pPr marL="0" lvl="0" indent="0" algn="just">
-              <a:lnSpc>
-                <a:spcPct val="115000"/>
-              </a:lnSpc>
-              <a:buNone/>
-            </a:pPr>
-            <a:endParaRPr lang="es-CU" sz="2400" dirty="0">
-              <a:effectLst/>
-              <a:latin typeface="Arial" panose="020B0604020202020204" pitchFamily="34" charset="0"/>
-              <a:ea typeface="Calibri" panose="020F0502020204030204" pitchFamily="34" charset="0"/>
-            </a:endParaRPr>
-          </a:p>
         </p:txBody>
       </p:sp>
       <p:pic>
@@ -8995,8 +8987,8 @@
         </p:nvSpPr>
         <p:spPr bwMode="auto">
           <a:xfrm rot="10800000" flipV="1">
-            <a:off x="107503" y="2028350"/>
-            <a:ext cx="9145016" cy="5170646"/>
+            <a:off x="107503" y="2145028"/>
+            <a:ext cx="9145016" cy="4154984"/>
           </a:xfrm>
           <a:prstGeom prst="rect">
             <a:avLst/>
@@ -9073,253 +9065,6 @@
               </a:rPr>
               <a:t>Seguro</a:t>
             </a:r>
-            <a:r>
-              <a:rPr kumimoji="0" lang="en-US" altLang="en-US" sz="2400" b="0" i="0" u="none" strike="noStrike" cap="none" normalizeH="0" baseline="0" dirty="0">
-                <a:ln>
-                  <a:noFill/>
-                </a:ln>
-                <a:solidFill>
-                  <a:schemeClr val="tx1"/>
-                </a:solidFill>
-                <a:effectLst/>
-                <a:latin typeface="Arial" panose="020B0604020202020204" pitchFamily="34" charset="0"/>
-              </a:rPr>
-              <a:t>, </a:t>
-            </a:r>
-            <a:r>
-              <a:rPr kumimoji="0" lang="en-US" altLang="en-US" sz="2400" b="0" i="0" u="none" strike="noStrike" cap="none" normalizeH="0" baseline="0" dirty="0" err="1">
-                <a:ln>
-                  <a:noFill/>
-                </a:ln>
-                <a:solidFill>
-                  <a:schemeClr val="tx1"/>
-                </a:solidFill>
-                <a:effectLst/>
-                <a:latin typeface="Arial" panose="020B0604020202020204" pitchFamily="34" charset="0"/>
-              </a:rPr>
-              <a:t>mediante</a:t>
-            </a:r>
-            <a:r>
-              <a:rPr kumimoji="0" lang="en-US" altLang="en-US" sz="2400" b="0" i="0" u="none" strike="noStrike" cap="none" normalizeH="0" baseline="0" dirty="0">
-                <a:ln>
-                  <a:noFill/>
-                </a:ln>
-                <a:solidFill>
-                  <a:schemeClr val="tx1"/>
-                </a:solidFill>
-                <a:effectLst/>
-                <a:latin typeface="Arial" panose="020B0604020202020204" pitchFamily="34" charset="0"/>
-              </a:rPr>
-              <a:t> </a:t>
-            </a:r>
-            <a:r>
-              <a:rPr kumimoji="0" lang="en-US" altLang="en-US" sz="2400" b="0" i="0" u="none" strike="noStrike" cap="none" normalizeH="0" baseline="0" dirty="0" err="1">
-                <a:ln>
-                  <a:noFill/>
-                </a:ln>
-                <a:solidFill>
-                  <a:schemeClr val="tx1"/>
-                </a:solidFill>
-                <a:effectLst/>
-                <a:latin typeface="Arial" panose="020B0604020202020204" pitchFamily="34" charset="0"/>
-              </a:rPr>
-              <a:t>autenticación</a:t>
-            </a:r>
-            <a:r>
-              <a:rPr kumimoji="0" lang="en-US" altLang="en-US" sz="2400" b="0" i="0" u="none" strike="noStrike" cap="none" normalizeH="0" baseline="0" dirty="0">
-                <a:ln>
-                  <a:noFill/>
-                </a:ln>
-                <a:solidFill>
-                  <a:schemeClr val="tx1"/>
-                </a:solidFill>
-                <a:effectLst/>
-                <a:latin typeface="Arial" panose="020B0604020202020204" pitchFamily="34" charset="0"/>
-              </a:rPr>
-              <a:t>, </a:t>
-            </a:r>
-            <a:r>
-              <a:rPr kumimoji="0" lang="en-US" altLang="en-US" sz="2400" b="0" i="0" u="none" strike="noStrike" cap="none" normalizeH="0" baseline="0" dirty="0" err="1">
-                <a:ln>
-                  <a:noFill/>
-                </a:ln>
-                <a:solidFill>
-                  <a:schemeClr val="tx1"/>
-                </a:solidFill>
-                <a:effectLst/>
-                <a:latin typeface="Arial" panose="020B0604020202020204" pitchFamily="34" charset="0"/>
-              </a:rPr>
-              <a:t>autorización</a:t>
-            </a:r>
-            <a:r>
-              <a:rPr kumimoji="0" lang="en-US" altLang="en-US" sz="2400" b="0" i="0" u="none" strike="noStrike" cap="none" normalizeH="0" baseline="0" dirty="0">
-                <a:ln>
-                  <a:noFill/>
-                </a:ln>
-                <a:solidFill>
-                  <a:schemeClr val="tx1"/>
-                </a:solidFill>
-                <a:effectLst/>
-                <a:latin typeface="Arial" panose="020B0604020202020204" pitchFamily="34" charset="0"/>
-              </a:rPr>
-              <a:t>, </a:t>
-            </a:r>
-            <a:r>
-              <a:rPr kumimoji="0" lang="en-US" altLang="en-US" sz="2400" b="0" i="0" u="none" strike="noStrike" cap="none" normalizeH="0" baseline="0" dirty="0" err="1">
-                <a:ln>
-                  <a:noFill/>
-                </a:ln>
-                <a:solidFill>
-                  <a:schemeClr val="tx1"/>
-                </a:solidFill>
-                <a:effectLst/>
-                <a:latin typeface="Arial" panose="020B0604020202020204" pitchFamily="34" charset="0"/>
-              </a:rPr>
-              <a:t>encriptación</a:t>
-            </a:r>
-            <a:r>
-              <a:rPr kumimoji="0" lang="en-US" altLang="en-US" sz="2400" b="0" i="0" u="none" strike="noStrike" cap="none" normalizeH="0" baseline="0" dirty="0">
-                <a:ln>
-                  <a:noFill/>
-                </a:ln>
-                <a:solidFill>
-                  <a:schemeClr val="tx1"/>
-                </a:solidFill>
-                <a:effectLst/>
-                <a:latin typeface="Arial" panose="020B0604020202020204" pitchFamily="34" charset="0"/>
-              </a:rPr>
-              <a:t> de </a:t>
-            </a:r>
-            <a:r>
-              <a:rPr kumimoji="0" lang="en-US" altLang="en-US" sz="2400" b="0" i="0" u="none" strike="noStrike" cap="none" normalizeH="0" baseline="0" dirty="0" err="1">
-                <a:ln>
-                  <a:noFill/>
-                </a:ln>
-                <a:solidFill>
-                  <a:schemeClr val="tx1"/>
-                </a:solidFill>
-                <a:effectLst/>
-                <a:latin typeface="Arial" panose="020B0604020202020204" pitchFamily="34" charset="0"/>
-              </a:rPr>
-              <a:t>contraseñas</a:t>
-            </a:r>
-            <a:r>
-              <a:rPr kumimoji="0" lang="en-US" altLang="en-US" sz="2400" b="0" i="0" u="none" strike="noStrike" cap="none" normalizeH="0" baseline="0" dirty="0">
-                <a:ln>
-                  <a:noFill/>
-                </a:ln>
-                <a:solidFill>
-                  <a:schemeClr val="tx1"/>
-                </a:solidFill>
-                <a:effectLst/>
-                <a:latin typeface="Arial" panose="020B0604020202020204" pitchFamily="34" charset="0"/>
-              </a:rPr>
-              <a:t>, </a:t>
-            </a:r>
-            <a:r>
-              <a:rPr kumimoji="0" lang="en-US" altLang="en-US" sz="2400" b="0" i="0" u="none" strike="noStrike" cap="none" normalizeH="0" baseline="0" dirty="0" err="1">
-                <a:ln>
-                  <a:noFill/>
-                </a:ln>
-                <a:solidFill>
-                  <a:schemeClr val="tx1"/>
-                </a:solidFill>
-                <a:effectLst/>
-                <a:latin typeface="Arial" panose="020B0604020202020204" pitchFamily="34" charset="0"/>
-              </a:rPr>
-              <a:t>protección</a:t>
-            </a:r>
-            <a:r>
-              <a:rPr kumimoji="0" lang="en-US" altLang="en-US" sz="2400" b="0" i="0" u="none" strike="noStrike" cap="none" normalizeH="0" baseline="0" dirty="0">
-                <a:ln>
-                  <a:noFill/>
-                </a:ln>
-                <a:solidFill>
-                  <a:schemeClr val="tx1"/>
-                </a:solidFill>
-                <a:effectLst/>
-                <a:latin typeface="Arial" panose="020B0604020202020204" pitchFamily="34" charset="0"/>
-              </a:rPr>
-              <a:t> contra </a:t>
-            </a:r>
-            <a:r>
-              <a:rPr kumimoji="0" lang="en-US" altLang="en-US" sz="2400" b="0" i="0" u="none" strike="noStrike" cap="none" normalizeH="0" baseline="0" dirty="0" err="1">
-                <a:ln>
-                  <a:noFill/>
-                </a:ln>
-                <a:solidFill>
-                  <a:schemeClr val="tx1"/>
-                </a:solidFill>
-                <a:effectLst/>
-                <a:latin typeface="Arial" panose="020B0604020202020204" pitchFamily="34" charset="0"/>
-              </a:rPr>
-              <a:t>vulnerabilidades</a:t>
-            </a:r>
-            <a:r>
-              <a:rPr kumimoji="0" lang="en-US" altLang="en-US" sz="2400" b="0" i="0" u="none" strike="noStrike" cap="none" normalizeH="0" baseline="0" dirty="0">
-                <a:ln>
-                  <a:noFill/>
-                </a:ln>
-                <a:solidFill>
-                  <a:schemeClr val="tx1"/>
-                </a:solidFill>
-                <a:effectLst/>
-                <a:latin typeface="Arial" panose="020B0604020202020204" pitchFamily="34" charset="0"/>
-              </a:rPr>
-              <a:t> y control de </a:t>
-            </a:r>
-            <a:r>
-              <a:rPr kumimoji="0" lang="en-US" altLang="en-US" sz="2400" b="0" i="0" u="none" strike="noStrike" cap="none" normalizeH="0" baseline="0" dirty="0" err="1">
-                <a:ln>
-                  <a:noFill/>
-                </a:ln>
-                <a:solidFill>
-                  <a:schemeClr val="tx1"/>
-                </a:solidFill>
-                <a:effectLst/>
-                <a:latin typeface="Arial" panose="020B0604020202020204" pitchFamily="34" charset="0"/>
-              </a:rPr>
-              <a:t>acceso</a:t>
-            </a:r>
-            <a:r>
-              <a:rPr kumimoji="0" lang="en-US" altLang="en-US" sz="2400" b="0" i="0" u="none" strike="noStrike" cap="none" normalizeH="0" baseline="0" dirty="0">
-                <a:ln>
-                  <a:noFill/>
-                </a:ln>
-                <a:solidFill>
-                  <a:schemeClr val="tx1"/>
-                </a:solidFill>
-                <a:effectLst/>
-                <a:latin typeface="Arial" panose="020B0604020202020204" pitchFamily="34" charset="0"/>
-              </a:rPr>
-              <a:t> a la base de </a:t>
-            </a:r>
-            <a:r>
-              <a:rPr kumimoji="0" lang="en-US" altLang="en-US" sz="2400" b="0" i="0" u="none" strike="noStrike" cap="none" normalizeH="0" baseline="0" dirty="0" err="1">
-                <a:ln>
-                  <a:noFill/>
-                </a:ln>
-                <a:solidFill>
-                  <a:schemeClr val="tx1"/>
-                </a:solidFill>
-                <a:effectLst/>
-                <a:latin typeface="Arial" panose="020B0604020202020204" pitchFamily="34" charset="0"/>
-              </a:rPr>
-              <a:t>datos</a:t>
-            </a:r>
-            <a:r>
-              <a:rPr kumimoji="0" lang="en-US" altLang="en-US" sz="2400" b="0" i="0" u="none" strike="noStrike" cap="none" normalizeH="0" baseline="0" dirty="0">
-                <a:ln>
-                  <a:noFill/>
-                </a:ln>
-                <a:solidFill>
-                  <a:schemeClr val="tx1"/>
-                </a:solidFill>
-                <a:effectLst/>
-                <a:latin typeface="Arial" panose="020B0604020202020204" pitchFamily="34" charset="0"/>
-              </a:rPr>
-              <a:t>.</a:t>
-            </a:r>
           </a:p>
           <a:p>
             <a:pPr marL="0" marR="0" lvl="0" indent="0" algn="l" defTabSz="914400" rtl="0" eaLnBrk="0" fontAlgn="base" latinLnBrk="0" hangingPunct="0">
@@ -9338,266 +9083,16 @@
               <a:buChar char="•"/>
               <a:tabLst/>
             </a:pPr>
-            <a:r>
-              <a:rPr kumimoji="0" lang="en-US" altLang="en-US" sz="2400" b="1" i="0" u="none" strike="noStrike" cap="none" normalizeH="0" baseline="0" dirty="0">
-                <a:ln>
-                  <a:noFill/>
-                </a:ln>
-                <a:solidFill>
-                  <a:schemeClr val="tx1"/>
-                </a:solidFill>
-                <a:effectLst/>
-                <a:latin typeface="Arial" panose="020B0604020202020204" pitchFamily="34" charset="0"/>
-              </a:rPr>
-              <a:t>Usable</a:t>
-            </a:r>
-            <a:r>
-              <a:rPr kumimoji="0" lang="en-US" altLang="en-US" sz="2400" b="0" i="0" u="none" strike="noStrike" cap="none" normalizeH="0" baseline="0" dirty="0">
-                <a:ln>
-                  <a:noFill/>
-                </a:ln>
-                <a:solidFill>
-                  <a:schemeClr val="tx1"/>
-                </a:solidFill>
-                <a:effectLst/>
-                <a:latin typeface="Arial" panose="020B0604020202020204" pitchFamily="34" charset="0"/>
-              </a:rPr>
-              <a:t>, con </a:t>
-            </a:r>
-            <a:r>
-              <a:rPr kumimoji="0" lang="en-US" altLang="en-US" sz="2400" b="0" i="0" u="none" strike="noStrike" cap="none" normalizeH="0" baseline="0" dirty="0" err="1">
-                <a:ln>
-                  <a:noFill/>
-                </a:ln>
-                <a:solidFill>
-                  <a:schemeClr val="tx1"/>
-                </a:solidFill>
-                <a:effectLst/>
-                <a:latin typeface="Arial" panose="020B0604020202020204" pitchFamily="34" charset="0"/>
-              </a:rPr>
-              <a:t>una</a:t>
-            </a:r>
-            <a:r>
-              <a:rPr kumimoji="0" lang="en-US" altLang="en-US" sz="2400" b="0" i="0" u="none" strike="noStrike" cap="none" normalizeH="0" baseline="0" dirty="0">
-                <a:ln>
-                  <a:noFill/>
-                </a:ln>
-                <a:solidFill>
-                  <a:schemeClr val="tx1"/>
-                </a:solidFill>
-                <a:effectLst/>
-                <a:latin typeface="Arial" panose="020B0604020202020204" pitchFamily="34" charset="0"/>
-              </a:rPr>
-              <a:t> </a:t>
-            </a:r>
-            <a:r>
-              <a:rPr kumimoji="0" lang="en-US" altLang="en-US" sz="2400" b="0" i="0" u="none" strike="noStrike" cap="none" normalizeH="0" baseline="0" dirty="0" err="1">
-                <a:ln>
-                  <a:noFill/>
-                </a:ln>
-                <a:solidFill>
-                  <a:schemeClr val="tx1"/>
-                </a:solidFill>
-                <a:effectLst/>
-                <a:latin typeface="Arial" panose="020B0604020202020204" pitchFamily="34" charset="0"/>
-              </a:rPr>
-              <a:t>interfaz</a:t>
-            </a:r>
-            <a:r>
-              <a:rPr kumimoji="0" lang="en-US" altLang="en-US" sz="2400" b="0" i="0" u="none" strike="noStrike" cap="none" normalizeH="0" baseline="0" dirty="0">
-                <a:ln>
-                  <a:noFill/>
-                </a:ln>
-                <a:solidFill>
-                  <a:schemeClr val="tx1"/>
-                </a:solidFill>
-                <a:effectLst/>
-                <a:latin typeface="Arial" panose="020B0604020202020204" pitchFamily="34" charset="0"/>
-              </a:rPr>
-              <a:t> </a:t>
-            </a:r>
-            <a:r>
-              <a:rPr kumimoji="0" lang="en-US" altLang="en-US" sz="2400" b="0" i="0" u="none" strike="noStrike" cap="none" normalizeH="0" baseline="0" dirty="0" err="1">
-                <a:ln>
-                  <a:noFill/>
-                </a:ln>
-                <a:solidFill>
-                  <a:schemeClr val="tx1"/>
-                </a:solidFill>
-                <a:effectLst/>
-                <a:latin typeface="Arial" panose="020B0604020202020204" pitchFamily="34" charset="0"/>
-              </a:rPr>
-              <a:t>intuitiva</a:t>
-            </a:r>
-            <a:r>
-              <a:rPr kumimoji="0" lang="en-US" altLang="en-US" sz="2400" b="0" i="0" u="none" strike="noStrike" cap="none" normalizeH="0" baseline="0" dirty="0">
-                <a:ln>
-                  <a:noFill/>
-                </a:ln>
-                <a:solidFill>
-                  <a:schemeClr val="tx1"/>
-                </a:solidFill>
-                <a:effectLst/>
-                <a:latin typeface="Arial" panose="020B0604020202020204" pitchFamily="34" charset="0"/>
-              </a:rPr>
-              <a:t>, </a:t>
-            </a:r>
-            <a:r>
-              <a:rPr kumimoji="0" lang="en-US" altLang="en-US" sz="2400" b="0" i="0" u="none" strike="noStrike" cap="none" normalizeH="0" baseline="0" dirty="0" err="1">
-                <a:ln>
-                  <a:noFill/>
-                </a:ln>
-                <a:solidFill>
-                  <a:schemeClr val="tx1"/>
-                </a:solidFill>
-                <a:effectLst/>
-                <a:latin typeface="Arial" panose="020B0604020202020204" pitchFamily="34" charset="0"/>
-              </a:rPr>
-              <a:t>accesible</a:t>
-            </a:r>
-            <a:r>
-              <a:rPr kumimoji="0" lang="en-US" altLang="en-US" sz="2400" b="0" i="0" u="none" strike="noStrike" cap="none" normalizeH="0" baseline="0" dirty="0">
-                <a:ln>
-                  <a:noFill/>
-                </a:ln>
-                <a:solidFill>
-                  <a:schemeClr val="tx1"/>
-                </a:solidFill>
-                <a:effectLst/>
-                <a:latin typeface="Arial" panose="020B0604020202020204" pitchFamily="34" charset="0"/>
-              </a:rPr>
-              <a:t>, </a:t>
-            </a:r>
-            <a:r>
-              <a:rPr kumimoji="0" lang="en-US" altLang="en-US" sz="2400" b="0" i="0" u="none" strike="noStrike" cap="none" normalizeH="0" baseline="0" dirty="0" err="1">
-                <a:ln>
-                  <a:noFill/>
-                </a:ln>
-                <a:solidFill>
-                  <a:schemeClr val="tx1"/>
-                </a:solidFill>
-                <a:effectLst/>
-                <a:latin typeface="Arial" panose="020B0604020202020204" pitchFamily="34" charset="0"/>
-              </a:rPr>
-              <a:t>fácil</a:t>
-            </a:r>
-            <a:r>
-              <a:rPr kumimoji="0" lang="en-US" altLang="en-US" sz="2400" b="0" i="0" u="none" strike="noStrike" cap="none" normalizeH="0" baseline="0" dirty="0">
-                <a:ln>
-                  <a:noFill/>
-                </a:ln>
-                <a:solidFill>
-                  <a:schemeClr val="tx1"/>
-                </a:solidFill>
-                <a:effectLst/>
-                <a:latin typeface="Arial" panose="020B0604020202020204" pitchFamily="34" charset="0"/>
-              </a:rPr>
-              <a:t> de usar y </a:t>
-            </a:r>
-            <a:r>
-              <a:rPr kumimoji="0" lang="en-US" altLang="en-US" sz="2400" b="0" i="0" u="none" strike="noStrike" cap="none" normalizeH="0" baseline="0" dirty="0" err="1">
-                <a:ln>
-                  <a:noFill/>
-                </a:ln>
-                <a:solidFill>
-                  <a:schemeClr val="tx1"/>
-                </a:solidFill>
-                <a:effectLst/>
-                <a:latin typeface="Arial" panose="020B0604020202020204" pitchFamily="34" charset="0"/>
-              </a:rPr>
-              <a:t>enfocada</a:t>
-            </a:r>
-            <a:r>
-              <a:rPr kumimoji="0" lang="en-US" altLang="en-US" sz="2400" b="0" i="0" u="none" strike="noStrike" cap="none" normalizeH="0" baseline="0" dirty="0">
-                <a:ln>
-                  <a:noFill/>
-                </a:ln>
-                <a:solidFill>
-                  <a:schemeClr val="tx1"/>
-                </a:solidFill>
-                <a:effectLst/>
-                <a:latin typeface="Arial" panose="020B0604020202020204" pitchFamily="34" charset="0"/>
-              </a:rPr>
-              <a:t> </a:t>
-            </a:r>
-            <a:r>
-              <a:rPr kumimoji="0" lang="en-US" altLang="en-US" sz="2400" b="0" i="0" u="none" strike="noStrike" cap="none" normalizeH="0" baseline="0" dirty="0" err="1">
-                <a:ln>
-                  <a:noFill/>
-                </a:ln>
-                <a:solidFill>
-                  <a:schemeClr val="tx1"/>
-                </a:solidFill>
-                <a:effectLst/>
-                <a:latin typeface="Arial" panose="020B0604020202020204" pitchFamily="34" charset="0"/>
-              </a:rPr>
-              <a:t>en</a:t>
-            </a:r>
-            <a:r>
-              <a:rPr kumimoji="0" lang="en-US" altLang="en-US" sz="2400" b="0" i="0" u="none" strike="noStrike" cap="none" normalizeH="0" baseline="0" dirty="0">
-                <a:ln>
-                  <a:noFill/>
-                </a:ln>
-                <a:solidFill>
-                  <a:schemeClr val="tx1"/>
-                </a:solidFill>
-                <a:effectLst/>
-                <a:latin typeface="Arial" panose="020B0604020202020204" pitchFamily="34" charset="0"/>
-              </a:rPr>
-              <a:t> la </a:t>
-            </a:r>
-            <a:r>
-              <a:rPr kumimoji="0" lang="en-US" altLang="en-US" sz="2400" b="0" i="0" u="none" strike="noStrike" cap="none" normalizeH="0" baseline="0" dirty="0" err="1">
-                <a:ln>
-                  <a:noFill/>
-                </a:ln>
-                <a:solidFill>
-                  <a:schemeClr val="tx1"/>
-                </a:solidFill>
-                <a:effectLst/>
-                <a:latin typeface="Arial" panose="020B0604020202020204" pitchFamily="34" charset="0"/>
-              </a:rPr>
-              <a:t>satisfacción</a:t>
-            </a:r>
-            <a:r>
-              <a:rPr kumimoji="0" lang="en-US" altLang="en-US" sz="2400" b="0" i="0" u="none" strike="noStrike" cap="none" normalizeH="0" baseline="0" dirty="0">
-                <a:ln>
-                  <a:noFill/>
-                </a:ln>
-                <a:solidFill>
-                  <a:schemeClr val="tx1"/>
-                </a:solidFill>
-                <a:effectLst/>
-                <a:latin typeface="Arial" panose="020B0604020202020204" pitchFamily="34" charset="0"/>
-              </a:rPr>
-              <a:t> del </a:t>
-            </a:r>
-            <a:r>
-              <a:rPr kumimoji="0" lang="en-US" altLang="en-US" sz="2400" b="0" i="0" u="none" strike="noStrike" cap="none" normalizeH="0" baseline="0" dirty="0" err="1">
-                <a:ln>
-                  <a:noFill/>
-                </a:ln>
-                <a:solidFill>
-                  <a:schemeClr val="tx1"/>
-                </a:solidFill>
-                <a:effectLst/>
-                <a:latin typeface="Arial" panose="020B0604020202020204" pitchFamily="34" charset="0"/>
-              </a:rPr>
-              <a:t>usuario</a:t>
-            </a:r>
-            <a:r>
-              <a:rPr kumimoji="0" lang="en-US" altLang="en-US" sz="2400" b="0" i="0" u="none" strike="noStrike" cap="none" normalizeH="0" baseline="0" dirty="0">
-                <a:ln>
-                  <a:noFill/>
-                </a:ln>
-                <a:solidFill>
-                  <a:schemeClr val="tx1"/>
-                </a:solidFill>
-                <a:effectLst/>
-                <a:latin typeface="Arial" panose="020B0604020202020204" pitchFamily="34" charset="0"/>
-              </a:rPr>
-              <a:t>.</a:t>
-            </a:r>
+            <a:endParaRPr kumimoji="0" lang="en-US" altLang="en-US" sz="2400" b="1" i="0" u="none" strike="noStrike" cap="none" normalizeH="0" baseline="0" dirty="0">
+              <a:ln>
+                <a:noFill/>
+              </a:ln>
+              <a:solidFill>
+                <a:schemeClr val="tx1"/>
+              </a:solidFill>
+              <a:effectLst/>
+              <a:latin typeface="Arial" panose="020B0604020202020204" pitchFamily="34" charset="0"/>
+            </a:endParaRPr>
           </a:p>
           <a:p>
             <a:pPr marL="0" marR="0" lvl="0" indent="0" algn="l" defTabSz="914400" rtl="0" eaLnBrk="0" fontAlgn="base" latinLnBrk="0" hangingPunct="0">
@@ -9627,176 +9122,7 @@
                 <a:effectLst/>
                 <a:latin typeface="Arial" panose="020B0604020202020204" pitchFamily="34" charset="0"/>
               </a:rPr>
-              <a:t>Disponible</a:t>
-            </a:r>
-            <a:r>
-              <a:rPr kumimoji="0" lang="en-US" altLang="en-US" sz="2400" b="0" i="0" u="none" strike="noStrike" cap="none" normalizeH="0" baseline="0" dirty="0">
-                <a:ln>
-                  <a:noFill/>
-                </a:ln>
-                <a:solidFill>
-                  <a:schemeClr val="tx1"/>
-                </a:solidFill>
-                <a:effectLst/>
-                <a:latin typeface="Arial" panose="020B0604020202020204" pitchFamily="34" charset="0"/>
-              </a:rPr>
-              <a:t>, </a:t>
-            </a:r>
-            <a:r>
-              <a:rPr kumimoji="0" lang="en-US" altLang="en-US" sz="2400" b="0" i="0" u="none" strike="noStrike" cap="none" normalizeH="0" baseline="0" dirty="0" err="1">
-                <a:ln>
-                  <a:noFill/>
-                </a:ln>
-                <a:solidFill>
-                  <a:schemeClr val="tx1"/>
-                </a:solidFill>
-                <a:effectLst/>
-                <a:latin typeface="Arial" panose="020B0604020202020204" pitchFamily="34" charset="0"/>
-              </a:rPr>
-              <a:t>garantizando</a:t>
-            </a:r>
-            <a:r>
-              <a:rPr kumimoji="0" lang="en-US" altLang="en-US" sz="2400" b="0" i="0" u="none" strike="noStrike" cap="none" normalizeH="0" baseline="0" dirty="0">
-                <a:ln>
-                  <a:noFill/>
-                </a:ln>
-                <a:solidFill>
-                  <a:schemeClr val="tx1"/>
-                </a:solidFill>
-                <a:effectLst/>
-                <a:latin typeface="Arial" panose="020B0604020202020204" pitchFamily="34" charset="0"/>
-              </a:rPr>
-              <a:t> </a:t>
-            </a:r>
-            <a:r>
-              <a:rPr kumimoji="0" lang="en-US" altLang="en-US" sz="2400" b="0" i="0" u="none" strike="noStrike" cap="none" normalizeH="0" baseline="0" dirty="0" err="1">
-                <a:ln>
-                  <a:noFill/>
-                </a:ln>
-                <a:solidFill>
-                  <a:schemeClr val="tx1"/>
-                </a:solidFill>
-                <a:effectLst/>
-                <a:latin typeface="Arial" panose="020B0604020202020204" pitchFamily="34" charset="0"/>
-              </a:rPr>
-              <a:t>tiempos</a:t>
-            </a:r>
-            <a:r>
-              <a:rPr kumimoji="0" lang="en-US" altLang="en-US" sz="2400" b="0" i="0" u="none" strike="noStrike" cap="none" normalizeH="0" baseline="0" dirty="0">
-                <a:ln>
-                  <a:noFill/>
-                </a:ln>
-                <a:solidFill>
-                  <a:schemeClr val="tx1"/>
-                </a:solidFill>
-                <a:effectLst/>
-                <a:latin typeface="Arial" panose="020B0604020202020204" pitchFamily="34" charset="0"/>
-              </a:rPr>
-              <a:t> de </a:t>
-            </a:r>
-            <a:r>
-              <a:rPr kumimoji="0" lang="en-US" altLang="en-US" sz="2400" b="0" i="0" u="none" strike="noStrike" cap="none" normalizeH="0" baseline="0" dirty="0" err="1">
-                <a:ln>
-                  <a:noFill/>
-                </a:ln>
-                <a:solidFill>
-                  <a:schemeClr val="tx1"/>
-                </a:solidFill>
-                <a:effectLst/>
-                <a:latin typeface="Arial" panose="020B0604020202020204" pitchFamily="34" charset="0"/>
-              </a:rPr>
-              <a:t>actividad</a:t>
-            </a:r>
-            <a:r>
-              <a:rPr kumimoji="0" lang="en-US" altLang="en-US" sz="2400" b="0" i="0" u="none" strike="noStrike" cap="none" normalizeH="0" baseline="0" dirty="0">
-                <a:ln>
-                  <a:noFill/>
-                </a:ln>
-                <a:solidFill>
-                  <a:schemeClr val="tx1"/>
-                </a:solidFill>
-                <a:effectLst/>
-                <a:latin typeface="Arial" panose="020B0604020202020204" pitchFamily="34" charset="0"/>
-              </a:rPr>
-              <a:t> </a:t>
-            </a:r>
-            <a:r>
-              <a:rPr kumimoji="0" lang="en-US" altLang="en-US" sz="2400" b="0" i="0" u="none" strike="noStrike" cap="none" normalizeH="0" baseline="0" dirty="0" err="1">
-                <a:ln>
-                  <a:noFill/>
-                </a:ln>
-                <a:solidFill>
-                  <a:schemeClr val="tx1"/>
-                </a:solidFill>
-                <a:effectLst/>
-                <a:latin typeface="Arial" panose="020B0604020202020204" pitchFamily="34" charset="0"/>
-              </a:rPr>
-              <a:t>constantes</a:t>
-            </a:r>
-            <a:r>
-              <a:rPr kumimoji="0" lang="en-US" altLang="en-US" sz="2400" b="0" i="0" u="none" strike="noStrike" cap="none" normalizeH="0" baseline="0" dirty="0">
-                <a:ln>
-                  <a:noFill/>
-                </a:ln>
-                <a:solidFill>
-                  <a:schemeClr val="tx1"/>
-                </a:solidFill>
-                <a:effectLst/>
-                <a:latin typeface="Arial" panose="020B0604020202020204" pitchFamily="34" charset="0"/>
-              </a:rPr>
-              <a:t>, con planes de </a:t>
-            </a:r>
-            <a:r>
-              <a:rPr kumimoji="0" lang="en-US" altLang="en-US" sz="2400" b="0" i="0" u="none" strike="noStrike" cap="none" normalizeH="0" baseline="0" dirty="0" err="1">
-                <a:ln>
-                  <a:noFill/>
-                </a:ln>
-                <a:solidFill>
-                  <a:schemeClr val="tx1"/>
-                </a:solidFill>
-                <a:effectLst/>
-                <a:latin typeface="Arial" panose="020B0604020202020204" pitchFamily="34" charset="0"/>
-              </a:rPr>
-              <a:t>recuperación</a:t>
-            </a:r>
-            <a:r>
-              <a:rPr kumimoji="0" lang="en-US" altLang="en-US" sz="2400" b="0" i="0" u="none" strike="noStrike" cap="none" normalizeH="0" baseline="0" dirty="0">
-                <a:ln>
-                  <a:noFill/>
-                </a:ln>
-                <a:solidFill>
-                  <a:schemeClr val="tx1"/>
-                </a:solidFill>
-                <a:effectLst/>
-                <a:latin typeface="Arial" panose="020B0604020202020204" pitchFamily="34" charset="0"/>
-              </a:rPr>
-              <a:t> ante </a:t>
-            </a:r>
-            <a:r>
-              <a:rPr kumimoji="0" lang="en-US" altLang="en-US" sz="2400" b="0" i="0" u="none" strike="noStrike" cap="none" normalizeH="0" baseline="0" dirty="0" err="1">
-                <a:ln>
-                  <a:noFill/>
-                </a:ln>
-                <a:solidFill>
-                  <a:schemeClr val="tx1"/>
-                </a:solidFill>
-                <a:effectLst/>
-                <a:latin typeface="Arial" panose="020B0604020202020204" pitchFamily="34" charset="0"/>
-              </a:rPr>
-              <a:t>fallos</a:t>
-            </a:r>
-            <a:r>
-              <a:rPr kumimoji="0" lang="en-US" altLang="en-US" sz="2400" b="0" i="0" u="none" strike="noStrike" cap="none" normalizeH="0" baseline="0" dirty="0">
-                <a:ln>
-                  <a:noFill/>
-                </a:ln>
-                <a:solidFill>
-                  <a:schemeClr val="tx1"/>
-                </a:solidFill>
-                <a:effectLst/>
-                <a:latin typeface="Arial" panose="020B0604020202020204" pitchFamily="34" charset="0"/>
-              </a:rPr>
-              <a:t>.</a:t>
+              <a:t>Usable</a:t>
             </a:r>
           </a:p>
           <a:p>
@@ -9816,536 +9142,16 @@
               <a:buChar char="•"/>
               <a:tabLst/>
             </a:pPr>
-            <a:r>
-              <a:rPr kumimoji="0" lang="en-US" altLang="en-US" sz="2400" b="1" i="0" u="none" strike="noStrike" cap="none" normalizeH="0" baseline="0" dirty="0" err="1">
-                <a:ln>
-                  <a:noFill/>
-                </a:ln>
-                <a:solidFill>
-                  <a:schemeClr val="tx1"/>
-                </a:solidFill>
-                <a:effectLst/>
-                <a:latin typeface="Arial" panose="020B0604020202020204" pitchFamily="34" charset="0"/>
-              </a:rPr>
-              <a:t>Fiable</a:t>
-            </a:r>
-            <a:r>
-              <a:rPr kumimoji="0" lang="en-US" altLang="en-US" sz="2400" b="0" i="0" u="none" strike="noStrike" cap="none" normalizeH="0" baseline="0" dirty="0">
-                <a:ln>
-                  <a:noFill/>
-                </a:ln>
-                <a:solidFill>
-                  <a:schemeClr val="tx1"/>
-                </a:solidFill>
-                <a:effectLst/>
-                <a:latin typeface="Arial" panose="020B0604020202020204" pitchFamily="34" charset="0"/>
-              </a:rPr>
-              <a:t>, </a:t>
-            </a:r>
-            <a:r>
-              <a:rPr kumimoji="0" lang="en-US" altLang="en-US" sz="2400" b="0" i="0" u="none" strike="noStrike" cap="none" normalizeH="0" baseline="0" dirty="0" err="1">
-                <a:ln>
-                  <a:noFill/>
-                </a:ln>
-                <a:solidFill>
-                  <a:schemeClr val="tx1"/>
-                </a:solidFill>
-                <a:effectLst/>
-                <a:latin typeface="Arial" panose="020B0604020202020204" pitchFamily="34" charset="0"/>
-              </a:rPr>
-              <a:t>ofreciendo</a:t>
-            </a:r>
-            <a:r>
-              <a:rPr kumimoji="0" lang="en-US" altLang="en-US" sz="2400" b="0" i="0" u="none" strike="noStrike" cap="none" normalizeH="0" baseline="0" dirty="0">
-                <a:ln>
-                  <a:noFill/>
-                </a:ln>
-                <a:solidFill>
-                  <a:schemeClr val="tx1"/>
-                </a:solidFill>
-                <a:effectLst/>
-                <a:latin typeface="Arial" panose="020B0604020202020204" pitchFamily="34" charset="0"/>
-              </a:rPr>
-              <a:t> </a:t>
-            </a:r>
-            <a:r>
-              <a:rPr kumimoji="0" lang="en-US" altLang="en-US" sz="2400" b="0" i="0" u="none" strike="noStrike" cap="none" normalizeH="0" baseline="0" dirty="0" err="1">
-                <a:ln>
-                  <a:noFill/>
-                </a:ln>
-                <a:solidFill>
-                  <a:schemeClr val="tx1"/>
-                </a:solidFill>
-                <a:effectLst/>
-                <a:latin typeface="Arial" panose="020B0604020202020204" pitchFamily="34" charset="0"/>
-              </a:rPr>
-              <a:t>tolerancia</a:t>
-            </a:r>
-            <a:r>
-              <a:rPr kumimoji="0" lang="en-US" altLang="en-US" sz="2400" b="0" i="0" u="none" strike="noStrike" cap="none" normalizeH="0" baseline="0" dirty="0">
-                <a:ln>
-                  <a:noFill/>
-                </a:ln>
-                <a:solidFill>
-                  <a:schemeClr val="tx1"/>
-                </a:solidFill>
-                <a:effectLst/>
-                <a:latin typeface="Arial" panose="020B0604020202020204" pitchFamily="34" charset="0"/>
-              </a:rPr>
-              <a:t> a </a:t>
-            </a:r>
-            <a:r>
-              <a:rPr kumimoji="0" lang="en-US" altLang="en-US" sz="2400" b="0" i="0" u="none" strike="noStrike" cap="none" normalizeH="0" baseline="0" dirty="0" err="1">
-                <a:ln>
-                  <a:noFill/>
-                </a:ln>
-                <a:solidFill>
-                  <a:schemeClr val="tx1"/>
-                </a:solidFill>
-                <a:effectLst/>
-                <a:latin typeface="Arial" panose="020B0604020202020204" pitchFamily="34" charset="0"/>
-              </a:rPr>
-              <a:t>errores</a:t>
-            </a:r>
-            <a:r>
-              <a:rPr kumimoji="0" lang="en-US" altLang="en-US" sz="2400" b="0" i="0" u="none" strike="noStrike" cap="none" normalizeH="0" baseline="0" dirty="0">
-                <a:ln>
-                  <a:noFill/>
-                </a:ln>
-                <a:solidFill>
-                  <a:schemeClr val="tx1"/>
-                </a:solidFill>
-                <a:effectLst/>
-                <a:latin typeface="Arial" panose="020B0604020202020204" pitchFamily="34" charset="0"/>
-              </a:rPr>
-              <a:t>, </a:t>
-            </a:r>
-            <a:r>
-              <a:rPr kumimoji="0" lang="en-US" altLang="en-US" sz="2400" b="0" i="0" u="none" strike="noStrike" cap="none" normalizeH="0" baseline="0" dirty="0" err="1">
-                <a:ln>
-                  <a:noFill/>
-                </a:ln>
-                <a:solidFill>
-                  <a:schemeClr val="tx1"/>
-                </a:solidFill>
-                <a:effectLst/>
-                <a:latin typeface="Arial" panose="020B0604020202020204" pitchFamily="34" charset="0"/>
-              </a:rPr>
-              <a:t>estabilidad</a:t>
-            </a:r>
-            <a:r>
-              <a:rPr kumimoji="0" lang="en-US" altLang="en-US" sz="2400" b="0" i="0" u="none" strike="noStrike" cap="none" normalizeH="0" baseline="0" dirty="0">
-                <a:ln>
-                  <a:noFill/>
-                </a:ln>
-                <a:solidFill>
-                  <a:schemeClr val="tx1"/>
-                </a:solidFill>
-                <a:effectLst/>
-                <a:latin typeface="Arial" panose="020B0604020202020204" pitchFamily="34" charset="0"/>
-              </a:rPr>
-              <a:t> y </a:t>
-            </a:r>
-            <a:r>
-              <a:rPr kumimoji="0" lang="en-US" altLang="en-US" sz="2400" b="0" i="0" u="none" strike="noStrike" cap="none" normalizeH="0" baseline="0" dirty="0" err="1">
-                <a:ln>
-                  <a:noFill/>
-                </a:ln>
-                <a:solidFill>
-                  <a:schemeClr val="tx1"/>
-                </a:solidFill>
-                <a:effectLst/>
-                <a:latin typeface="Arial" panose="020B0604020202020204" pitchFamily="34" charset="0"/>
-              </a:rPr>
-              <a:t>recuperación</a:t>
-            </a:r>
-            <a:r>
-              <a:rPr kumimoji="0" lang="en-US" altLang="en-US" sz="2400" b="0" i="0" u="none" strike="noStrike" cap="none" normalizeH="0" baseline="0" dirty="0">
-                <a:ln>
-                  <a:noFill/>
-                </a:ln>
-                <a:solidFill>
-                  <a:schemeClr val="tx1"/>
-                </a:solidFill>
-                <a:effectLst/>
-                <a:latin typeface="Arial" panose="020B0604020202020204" pitchFamily="34" charset="0"/>
-              </a:rPr>
-              <a:t> </a:t>
-            </a:r>
-            <a:r>
-              <a:rPr kumimoji="0" lang="en-US" altLang="en-US" sz="2400" b="0" i="0" u="none" strike="noStrike" cap="none" normalizeH="0" baseline="0" dirty="0" err="1">
-                <a:ln>
-                  <a:noFill/>
-                </a:ln>
-                <a:solidFill>
-                  <a:schemeClr val="tx1"/>
-                </a:solidFill>
-                <a:effectLst/>
-                <a:latin typeface="Arial" panose="020B0604020202020204" pitchFamily="34" charset="0"/>
-              </a:rPr>
-              <a:t>efectiva</a:t>
-            </a:r>
-            <a:r>
-              <a:rPr kumimoji="0" lang="en-US" altLang="en-US" sz="2400" b="0" i="0" u="none" strike="noStrike" cap="none" normalizeH="0" baseline="0" dirty="0">
-                <a:ln>
-                  <a:noFill/>
-                </a:ln>
-                <a:solidFill>
-                  <a:schemeClr val="tx1"/>
-                </a:solidFill>
-                <a:effectLst/>
-                <a:latin typeface="Arial" panose="020B0604020202020204" pitchFamily="34" charset="0"/>
-              </a:rPr>
-              <a:t>.</a:t>
-            </a:r>
-          </a:p>
-          <a:p>
-            <a:pPr eaLnBrk="0" fontAlgn="base" hangingPunct="0">
-              <a:spcBef>
-                <a:spcPct val="0"/>
-              </a:spcBef>
-              <a:spcAft>
-                <a:spcPct val="0"/>
-              </a:spcAft>
-              <a:buFontTx/>
-              <a:buChar char="•"/>
-            </a:pPr>
-            <a:r>
-              <a:rPr kumimoji="0" lang="en-US" altLang="en-US" sz="2400" b="1" i="0" u="none" strike="noStrike" cap="none" normalizeH="0" baseline="0" dirty="0" err="1">
-                <a:ln>
-                  <a:noFill/>
-                </a:ln>
-                <a:solidFill>
-                  <a:schemeClr val="tx1"/>
-                </a:solidFill>
-                <a:effectLst/>
-                <a:latin typeface="Arial" panose="020B0604020202020204" pitchFamily="34" charset="0"/>
-              </a:rPr>
-              <a:t>Mantenible</a:t>
-            </a:r>
-            <a:r>
-              <a:rPr kumimoji="0" lang="en-US" altLang="en-US" sz="2400" b="0" i="0" u="none" strike="noStrike" cap="none" normalizeH="0" baseline="0" dirty="0">
-                <a:ln>
-                  <a:noFill/>
-                </a:ln>
-                <a:solidFill>
-                  <a:schemeClr val="tx1"/>
-                </a:solidFill>
-                <a:effectLst/>
-                <a:latin typeface="Arial" panose="020B0604020202020204" pitchFamily="34" charset="0"/>
-              </a:rPr>
-              <a:t>, con </a:t>
-            </a:r>
-            <a:r>
-              <a:rPr kumimoji="0" lang="en-US" altLang="en-US" sz="2400" b="0" i="0" u="none" strike="noStrike" cap="none" normalizeH="0" baseline="0" dirty="0" err="1">
-                <a:ln>
-                  <a:noFill/>
-                </a:ln>
-                <a:solidFill>
-                  <a:schemeClr val="tx1"/>
-                </a:solidFill>
-                <a:effectLst/>
-                <a:latin typeface="Arial" panose="020B0604020202020204" pitchFamily="34" charset="0"/>
-              </a:rPr>
-              <a:t>facilidad</a:t>
-            </a:r>
-            <a:r>
-              <a:rPr kumimoji="0" lang="en-US" altLang="en-US" sz="2400" b="0" i="0" u="none" strike="noStrike" cap="none" normalizeH="0" baseline="0" dirty="0">
-                <a:ln>
-                  <a:noFill/>
-                </a:ln>
-                <a:solidFill>
-                  <a:schemeClr val="tx1"/>
-                </a:solidFill>
-                <a:effectLst/>
-                <a:latin typeface="Arial" panose="020B0604020202020204" pitchFamily="34" charset="0"/>
-              </a:rPr>
-              <a:t> para </a:t>
-            </a:r>
-            <a:r>
-              <a:rPr kumimoji="0" lang="en-US" altLang="en-US" sz="2400" b="0" i="0" u="none" strike="noStrike" cap="none" normalizeH="0" baseline="0" dirty="0" err="1">
-                <a:ln>
-                  <a:noFill/>
-                </a:ln>
-                <a:solidFill>
-                  <a:schemeClr val="tx1"/>
-                </a:solidFill>
-                <a:effectLst/>
-                <a:latin typeface="Arial" panose="020B0604020202020204" pitchFamily="34" charset="0"/>
-              </a:rPr>
-              <a:t>actualizaciones</a:t>
-            </a:r>
-            <a:r>
-              <a:rPr kumimoji="0" lang="en-US" altLang="en-US" sz="2400" b="0" i="0" u="none" strike="noStrike" cap="none" normalizeH="0" baseline="0" dirty="0">
-                <a:ln>
-                  <a:noFill/>
-                </a:ln>
-                <a:solidFill>
-                  <a:schemeClr val="tx1"/>
-                </a:solidFill>
-                <a:effectLst/>
-                <a:latin typeface="Arial" panose="020B0604020202020204" pitchFamily="34" charset="0"/>
-              </a:rPr>
-              <a:t>, </a:t>
-            </a:r>
-            <a:r>
-              <a:rPr kumimoji="0" lang="en-US" altLang="en-US" sz="2400" b="0" i="0" u="none" strike="noStrike" cap="none" normalizeH="0" baseline="0" dirty="0" err="1">
-                <a:ln>
-                  <a:noFill/>
-                </a:ln>
-                <a:solidFill>
-                  <a:schemeClr val="tx1"/>
-                </a:solidFill>
-                <a:effectLst/>
-                <a:latin typeface="Arial" panose="020B0604020202020204" pitchFamily="34" charset="0"/>
-              </a:rPr>
-              <a:t>buena</a:t>
-            </a:r>
-            <a:r>
-              <a:rPr kumimoji="0" lang="en-US" altLang="en-US" sz="2400" b="0" i="0" u="none" strike="noStrike" cap="none" normalizeH="0" baseline="0" dirty="0">
-                <a:ln>
-                  <a:noFill/>
-                </a:ln>
-                <a:solidFill>
-                  <a:schemeClr val="tx1"/>
-                </a:solidFill>
-                <a:effectLst/>
-                <a:latin typeface="Arial" panose="020B0604020202020204" pitchFamily="34" charset="0"/>
-              </a:rPr>
-              <a:t> </a:t>
-            </a:r>
-            <a:r>
-              <a:rPr kumimoji="0" lang="en-US" altLang="en-US" sz="2400" b="0" i="0" u="none" strike="noStrike" cap="none" normalizeH="0" baseline="0" dirty="0" err="1">
-                <a:ln>
-                  <a:noFill/>
-                </a:ln>
-                <a:solidFill>
-                  <a:schemeClr val="tx1"/>
-                </a:solidFill>
-                <a:effectLst/>
-                <a:latin typeface="Arial" panose="020B0604020202020204" pitchFamily="34" charset="0"/>
-              </a:rPr>
-              <a:t>documentación</a:t>
-            </a:r>
-            <a:r>
-              <a:rPr kumimoji="0" lang="en-US" altLang="en-US" sz="2400" b="0" i="0" u="none" strike="noStrike" cap="none" normalizeH="0" baseline="0" dirty="0">
-                <a:ln>
-                  <a:noFill/>
-                </a:ln>
-                <a:solidFill>
-                  <a:schemeClr val="tx1"/>
-                </a:solidFill>
-                <a:effectLst/>
-                <a:latin typeface="Arial" panose="020B0604020202020204" pitchFamily="34" charset="0"/>
-              </a:rPr>
-              <a:t> y </a:t>
-            </a:r>
-            <a:r>
-              <a:rPr kumimoji="0" lang="en-US" altLang="en-US" sz="2400" b="0" i="0" u="none" strike="noStrike" cap="none" normalizeH="0" baseline="0" dirty="0" err="1">
-                <a:ln>
-                  <a:noFill/>
-                </a:ln>
-                <a:solidFill>
-                  <a:schemeClr val="tx1"/>
-                </a:solidFill>
-                <a:effectLst/>
-                <a:latin typeface="Arial" panose="020B0604020202020204" pitchFamily="34" charset="0"/>
-              </a:rPr>
-              <a:t>capacidad</a:t>
-            </a:r>
-            <a:r>
-              <a:rPr kumimoji="0" lang="en-US" altLang="en-US" sz="2400" b="0" i="0" u="none" strike="noStrike" cap="none" normalizeH="0" baseline="0" dirty="0">
-                <a:ln>
-                  <a:noFill/>
-                </a:ln>
-                <a:solidFill>
-                  <a:schemeClr val="tx1"/>
-                </a:solidFill>
-                <a:effectLst/>
-                <a:latin typeface="Arial" panose="020B0604020202020204" pitchFamily="34" charset="0"/>
-              </a:rPr>
-              <a:t> de </a:t>
-            </a:r>
-            <a:r>
-              <a:rPr kumimoji="0" lang="en-US" altLang="en-US" sz="2400" b="0" i="0" u="none" strike="noStrike" cap="none" normalizeH="0" baseline="0" dirty="0" err="1">
-                <a:ln>
-                  <a:noFill/>
-                </a:ln>
-                <a:solidFill>
-                  <a:schemeClr val="tx1"/>
-                </a:solidFill>
-                <a:effectLst/>
-                <a:latin typeface="Arial" panose="020B0604020202020204" pitchFamily="34" charset="0"/>
-              </a:rPr>
-              <a:t>cambio</a:t>
-            </a:r>
-            <a:r>
-              <a:rPr kumimoji="0" lang="en-US" altLang="en-US" sz="2400" b="0" i="0" u="none" strike="noStrike" cap="none" normalizeH="0" baseline="0" dirty="0">
-                <a:ln>
-                  <a:noFill/>
-                </a:ln>
-                <a:solidFill>
-                  <a:schemeClr val="tx1"/>
-                </a:solidFill>
-                <a:effectLst/>
-                <a:latin typeface="Arial" panose="020B0604020202020204" pitchFamily="34" charset="0"/>
-              </a:rPr>
-              <a:t> sin </a:t>
-            </a:r>
-            <a:r>
-              <a:rPr kumimoji="0" lang="en-US" altLang="en-US" sz="2400" b="0" i="0" u="none" strike="noStrike" cap="none" normalizeH="0" baseline="0" dirty="0" err="1">
-                <a:ln>
-                  <a:noFill/>
-                </a:ln>
-                <a:solidFill>
-                  <a:schemeClr val="tx1"/>
-                </a:solidFill>
-                <a:effectLst/>
-                <a:latin typeface="Arial" panose="020B0604020202020204" pitchFamily="34" charset="0"/>
-              </a:rPr>
-              <a:t>afectar</a:t>
-            </a:r>
-            <a:r>
-              <a:rPr kumimoji="0" lang="en-US" altLang="en-US" sz="2400" b="0" i="0" u="none" strike="noStrike" cap="none" normalizeH="0" baseline="0" dirty="0">
-                <a:ln>
-                  <a:noFill/>
-                </a:ln>
-                <a:solidFill>
-                  <a:schemeClr val="tx1"/>
-                </a:solidFill>
-                <a:effectLst/>
-                <a:latin typeface="Arial" panose="020B0604020202020204" pitchFamily="34" charset="0"/>
-              </a:rPr>
-              <a:t> la </a:t>
-            </a:r>
-            <a:r>
-              <a:rPr kumimoji="0" lang="en-US" altLang="en-US" sz="2400" b="0" i="0" u="none" strike="noStrike" cap="none" normalizeH="0" baseline="0" dirty="0" err="1">
-                <a:ln>
-                  <a:noFill/>
-                </a:ln>
-                <a:solidFill>
-                  <a:schemeClr val="tx1"/>
-                </a:solidFill>
-                <a:effectLst/>
-                <a:latin typeface="Arial" panose="020B0604020202020204" pitchFamily="34" charset="0"/>
-              </a:rPr>
-              <a:t>estabilidad</a:t>
-            </a:r>
-            <a:r>
-              <a:rPr kumimoji="0" lang="en-US" altLang="en-US" sz="2400" b="0" i="0" u="none" strike="noStrike" cap="none" normalizeH="0" baseline="0" dirty="0">
-                <a:ln>
-                  <a:noFill/>
-                </a:ln>
-                <a:solidFill>
-                  <a:schemeClr val="tx1"/>
-                </a:solidFill>
-                <a:effectLst/>
-                <a:latin typeface="Arial" panose="020B0604020202020204" pitchFamily="34" charset="0"/>
-              </a:rPr>
-              <a:t>.</a:t>
-            </a:r>
-            <a:r>
-              <a:rPr lang="en-US" altLang="en-US" sz="2400" b="1" dirty="0">
-                <a:latin typeface="Arial" panose="020B0604020202020204" pitchFamily="34" charset="0"/>
-              </a:rPr>
-              <a:t> </a:t>
-            </a:r>
-          </a:p>
-          <a:p>
-            <a:pPr eaLnBrk="0" fontAlgn="base" hangingPunct="0">
-              <a:spcBef>
-                <a:spcPct val="0"/>
-              </a:spcBef>
-              <a:spcAft>
-                <a:spcPct val="0"/>
-              </a:spcAft>
-              <a:buFontTx/>
-              <a:buChar char="•"/>
-            </a:pPr>
-            <a:r>
-              <a:rPr lang="en-US" altLang="en-US" sz="2400" b="1" dirty="0" err="1">
-                <a:latin typeface="Arial" panose="020B0604020202020204" pitchFamily="34" charset="0"/>
-              </a:rPr>
-              <a:t>Rápido</a:t>
-            </a:r>
-            <a:r>
-              <a:rPr lang="en-US" altLang="en-US" sz="2400" b="1" dirty="0">
-                <a:latin typeface="Arial" panose="020B0604020202020204" pitchFamily="34" charset="0"/>
-              </a:rPr>
-              <a:t> y </a:t>
-            </a:r>
-            <a:r>
-              <a:rPr lang="en-US" altLang="en-US" sz="2400" b="1" dirty="0" err="1">
-                <a:latin typeface="Arial" panose="020B0604020202020204" pitchFamily="34" charset="0"/>
-              </a:rPr>
-              <a:t>eficiente</a:t>
-            </a:r>
-            <a:r>
-              <a:rPr lang="en-US" altLang="en-US" sz="2400" dirty="0">
-                <a:latin typeface="Arial" panose="020B0604020202020204" pitchFamily="34" charset="0"/>
-              </a:rPr>
-              <a:t>, con </a:t>
-            </a:r>
-            <a:r>
-              <a:rPr lang="en-US" altLang="en-US" sz="2400" dirty="0" err="1">
-                <a:latin typeface="Arial" panose="020B0604020202020204" pitchFamily="34" charset="0"/>
-              </a:rPr>
-              <a:t>tiempos</a:t>
-            </a:r>
-            <a:r>
-              <a:rPr lang="en-US" altLang="en-US" sz="2400" dirty="0">
-                <a:latin typeface="Arial" panose="020B0604020202020204" pitchFamily="34" charset="0"/>
-              </a:rPr>
-              <a:t> de </a:t>
-            </a:r>
-            <a:r>
-              <a:rPr lang="en-US" altLang="en-US" sz="2400" dirty="0" err="1">
-                <a:latin typeface="Arial" panose="020B0604020202020204" pitchFamily="34" charset="0"/>
-              </a:rPr>
-              <a:t>respuesta</a:t>
-            </a:r>
-            <a:r>
-              <a:rPr lang="en-US" altLang="en-US" sz="2400" dirty="0">
-                <a:latin typeface="Arial" panose="020B0604020202020204" pitchFamily="34" charset="0"/>
-              </a:rPr>
-              <a:t> entre 2 y 3 </a:t>
-            </a:r>
-            <a:r>
-              <a:rPr lang="en-US" altLang="en-US" sz="2400" dirty="0" err="1">
-                <a:latin typeface="Arial" panose="020B0604020202020204" pitchFamily="34" charset="0"/>
-              </a:rPr>
-              <a:t>segundos</a:t>
-            </a:r>
-            <a:r>
-              <a:rPr lang="en-US" altLang="en-US" sz="2400" dirty="0">
-                <a:latin typeface="Arial" panose="020B0604020202020204" pitchFamily="34" charset="0"/>
-              </a:rPr>
-              <a:t> para </a:t>
-            </a:r>
-            <a:r>
-              <a:rPr lang="en-US" altLang="en-US" sz="2400" dirty="0" err="1">
-                <a:latin typeface="Arial" panose="020B0604020202020204" pitchFamily="34" charset="0"/>
-              </a:rPr>
-              <a:t>consultas</a:t>
-            </a:r>
-            <a:r>
-              <a:rPr lang="en-US" altLang="en-US" sz="2400" dirty="0">
-                <a:latin typeface="Arial" panose="020B0604020202020204" pitchFamily="34" charset="0"/>
-              </a:rPr>
-              <a:t> y </a:t>
-            </a:r>
-            <a:r>
-              <a:rPr lang="en-US" altLang="en-US" sz="2400" dirty="0" err="1">
-                <a:latin typeface="Arial" panose="020B0604020202020204" pitchFamily="34" charset="0"/>
-              </a:rPr>
-              <a:t>operaciones</a:t>
-            </a:r>
-            <a:r>
-              <a:rPr lang="en-US" altLang="en-US" sz="2400" dirty="0">
-                <a:latin typeface="Arial" panose="020B0604020202020204" pitchFamily="34" charset="0"/>
-              </a:rPr>
-              <a:t>.</a:t>
-            </a:r>
+            <a:endParaRPr kumimoji="0" lang="en-US" altLang="en-US" sz="2400" b="0" i="0" u="none" strike="noStrike" cap="none" normalizeH="0" baseline="0" dirty="0">
+              <a:ln>
+                <a:noFill/>
+              </a:ln>
+              <a:solidFill>
+                <a:schemeClr val="tx1"/>
+              </a:solidFill>
+              <a:effectLst/>
+              <a:latin typeface="Arial" panose="020B0604020202020204" pitchFamily="34" charset="0"/>
+            </a:endParaRPr>
           </a:p>
           <a:p>
             <a:pPr marL="0" marR="0" lvl="0" indent="0" algn="l" defTabSz="914400" rtl="0" eaLnBrk="0" fontAlgn="base" latinLnBrk="0" hangingPunct="0">
@@ -10364,6 +9170,214 @@
               <a:buChar char="•"/>
               <a:tabLst/>
             </a:pPr>
+            <a:r>
+              <a:rPr kumimoji="0" lang="en-US" altLang="en-US" sz="2400" b="1" i="0" u="none" strike="noStrike" cap="none" normalizeH="0" baseline="0" dirty="0">
+                <a:ln>
+                  <a:noFill/>
+                </a:ln>
+                <a:solidFill>
+                  <a:schemeClr val="tx1"/>
+                </a:solidFill>
+                <a:effectLst/>
+                <a:latin typeface="Arial" panose="020B0604020202020204" pitchFamily="34" charset="0"/>
+              </a:rPr>
+              <a:t>Disponible</a:t>
+            </a:r>
+          </a:p>
+          <a:p>
+            <a:pPr marL="0" marR="0" lvl="0" indent="0" algn="l" defTabSz="914400" rtl="0" eaLnBrk="0" fontAlgn="base" latinLnBrk="0" hangingPunct="0">
+              <a:lnSpc>
+                <a:spcPct val="100000"/>
+              </a:lnSpc>
+              <a:spcBef>
+                <a:spcPct val="0"/>
+              </a:spcBef>
+              <a:spcAft>
+                <a:spcPct val="0"/>
+              </a:spcAft>
+              <a:buClrTx/>
+              <a:buSzTx/>
+              <a:buFontTx/>
+              <a:buChar char="•"/>
+              <a:tabLst/>
+            </a:pPr>
+            <a:endParaRPr kumimoji="0" lang="en-US" altLang="en-US" sz="2400" b="0" i="0" u="none" strike="noStrike" cap="none" normalizeH="0" baseline="0" dirty="0">
+              <a:ln>
+                <a:noFill/>
+              </a:ln>
+              <a:solidFill>
+                <a:schemeClr val="tx1"/>
+              </a:solidFill>
+              <a:effectLst/>
+              <a:latin typeface="Arial" panose="020B0604020202020204" pitchFamily="34" charset="0"/>
+            </a:endParaRPr>
+          </a:p>
+          <a:p>
+            <a:pPr marL="0" marR="0" lvl="0" indent="0" algn="l" defTabSz="914400" rtl="0" eaLnBrk="0" fontAlgn="base" latinLnBrk="0" hangingPunct="0">
+              <a:lnSpc>
+                <a:spcPct val="100000"/>
+              </a:lnSpc>
+              <a:spcBef>
+                <a:spcPct val="0"/>
+              </a:spcBef>
+              <a:spcAft>
+                <a:spcPct val="0"/>
+              </a:spcAft>
+              <a:buClrTx/>
+              <a:buSzTx/>
+              <a:buFontTx/>
+              <a:buChar char="•"/>
+              <a:tabLst/>
+            </a:pPr>
+            <a:r>
+              <a:rPr kumimoji="0" lang="en-US" altLang="en-US" sz="2400" b="1" i="0" u="none" strike="noStrike" cap="none" normalizeH="0" baseline="0" dirty="0" err="1">
+                <a:ln>
+                  <a:noFill/>
+                </a:ln>
+                <a:solidFill>
+                  <a:schemeClr val="tx1"/>
+                </a:solidFill>
+                <a:effectLst/>
+                <a:latin typeface="Arial" panose="020B0604020202020204" pitchFamily="34" charset="0"/>
+              </a:rPr>
+              <a:t>Fiable</a:t>
+            </a:r>
+            <a:endParaRPr kumimoji="0" lang="en-US" altLang="en-US" sz="2400" b="1" i="0" u="none" strike="noStrike" cap="none" normalizeH="0" baseline="0" dirty="0">
+              <a:ln>
+                <a:noFill/>
+              </a:ln>
+              <a:solidFill>
+                <a:schemeClr val="tx1"/>
+              </a:solidFill>
+              <a:effectLst/>
+              <a:latin typeface="Arial" panose="020B0604020202020204" pitchFamily="34" charset="0"/>
+            </a:endParaRPr>
+          </a:p>
+          <a:p>
+            <a:pPr marL="0" marR="0" lvl="0" indent="0" algn="l" defTabSz="914400" rtl="0" eaLnBrk="0" fontAlgn="base" latinLnBrk="0" hangingPunct="0">
+              <a:lnSpc>
+                <a:spcPct val="100000"/>
+              </a:lnSpc>
+              <a:spcBef>
+                <a:spcPct val="0"/>
+              </a:spcBef>
+              <a:spcAft>
+                <a:spcPct val="0"/>
+              </a:spcAft>
+              <a:buClrTx/>
+              <a:buSzTx/>
+              <a:buFontTx/>
+              <a:buChar char="•"/>
+              <a:tabLst/>
+            </a:pPr>
+            <a:endParaRPr kumimoji="0" lang="en-US" altLang="en-US" sz="2400" b="0" i="0" u="none" strike="noStrike" cap="none" normalizeH="0" baseline="0" dirty="0">
+              <a:ln>
+                <a:noFill/>
+              </a:ln>
+              <a:solidFill>
+                <a:schemeClr val="tx1"/>
+              </a:solidFill>
+              <a:effectLst/>
+              <a:latin typeface="Arial" panose="020B0604020202020204" pitchFamily="34" charset="0"/>
+            </a:endParaRPr>
+          </a:p>
+          <a:p>
+            <a:pPr marL="0" marR="0" lvl="0" indent="0" algn="l" defTabSz="914400" rtl="0" eaLnBrk="0" fontAlgn="base" latinLnBrk="0" hangingPunct="0">
+              <a:lnSpc>
+                <a:spcPct val="100000"/>
+              </a:lnSpc>
+              <a:spcBef>
+                <a:spcPct val="0"/>
+              </a:spcBef>
+              <a:spcAft>
+                <a:spcPct val="0"/>
+              </a:spcAft>
+              <a:buClrTx/>
+              <a:buSzTx/>
+              <a:buFontTx/>
+              <a:buChar char="•"/>
+              <a:tabLst/>
+            </a:pPr>
+            <a:r>
+              <a:rPr kumimoji="0" lang="en-US" altLang="en-US" sz="2400" b="1" i="0" u="none" strike="noStrike" cap="none" normalizeH="0" baseline="0" dirty="0" err="1">
+                <a:ln>
+                  <a:noFill/>
+                </a:ln>
+                <a:solidFill>
+                  <a:schemeClr val="tx1"/>
+                </a:solidFill>
+                <a:effectLst/>
+                <a:latin typeface="Arial" panose="020B0604020202020204" pitchFamily="34" charset="0"/>
+              </a:rPr>
+              <a:t>Mantenible</a:t>
+            </a:r>
+            <a:endParaRPr kumimoji="0" lang="en-US" altLang="en-US" sz="2400" b="1" i="0" u="none" strike="noStrike" cap="none" normalizeH="0" baseline="0" dirty="0">
+              <a:ln>
+                <a:noFill/>
+              </a:ln>
+              <a:solidFill>
+                <a:schemeClr val="tx1"/>
+              </a:solidFill>
+              <a:effectLst/>
+              <a:latin typeface="Arial" panose="020B0604020202020204" pitchFamily="34" charset="0"/>
+            </a:endParaRPr>
+          </a:p>
+          <a:p>
+            <a:pPr marL="0" marR="0" lvl="0" indent="0" algn="l" defTabSz="914400" rtl="0" eaLnBrk="0" fontAlgn="base" latinLnBrk="0" hangingPunct="0">
+              <a:lnSpc>
+                <a:spcPct val="100000"/>
+              </a:lnSpc>
+              <a:spcBef>
+                <a:spcPct val="0"/>
+              </a:spcBef>
+              <a:spcAft>
+                <a:spcPct val="0"/>
+              </a:spcAft>
+              <a:buClrTx/>
+              <a:buSzTx/>
+              <a:buFontTx/>
+              <a:buChar char="•"/>
+              <a:tabLst/>
+            </a:pPr>
+            <a:endParaRPr lang="en-US" altLang="en-US" sz="2400" b="1" dirty="0">
+              <a:latin typeface="Arial" panose="020B0604020202020204" pitchFamily="34" charset="0"/>
+            </a:endParaRPr>
+          </a:p>
+          <a:p>
+            <a:pPr eaLnBrk="0" fontAlgn="base" hangingPunct="0">
+              <a:spcBef>
+                <a:spcPct val="0"/>
+              </a:spcBef>
+              <a:spcAft>
+                <a:spcPct val="0"/>
+              </a:spcAft>
+              <a:buFontTx/>
+              <a:buChar char="•"/>
+            </a:pPr>
+            <a:r>
+              <a:rPr lang="en-US" altLang="en-US" sz="2400" b="1" dirty="0" err="1">
+                <a:latin typeface="Arial" panose="020B0604020202020204" pitchFamily="34" charset="0"/>
+              </a:rPr>
+              <a:t>Rápido</a:t>
+            </a:r>
+            <a:r>
+              <a:rPr lang="en-US" altLang="en-US" sz="2400" b="1" dirty="0">
+                <a:latin typeface="Arial" panose="020B0604020202020204" pitchFamily="34" charset="0"/>
+              </a:rPr>
+              <a:t> y </a:t>
+            </a:r>
+            <a:r>
+              <a:rPr lang="en-US" altLang="en-US" sz="2400" b="1" dirty="0" err="1">
+                <a:latin typeface="Arial" panose="020B0604020202020204" pitchFamily="34" charset="0"/>
+              </a:rPr>
+              <a:t>eficiente</a:t>
+            </a:r>
+            <a:r>
+              <a:rPr lang="en-US" altLang="en-US" sz="2400" dirty="0">
+                <a:latin typeface="Arial" panose="020B0604020202020204" pitchFamily="34" charset="0"/>
+              </a:rPr>
+              <a:t> </a:t>
+            </a:r>
             <a:endParaRPr kumimoji="0" lang="en-US" altLang="en-US" sz="1800" b="0" i="0" u="none" strike="noStrike" cap="none" normalizeH="0" baseline="0" dirty="0">
               <a:ln>
                 <a:noFill/>
@@ -10489,84 +9503,12 @@
                   <a:schemeClr val="bg1"/>
                 </a:solidFill>
               </a:rPr>
-              <a:t>Arquitectura del Sistema</a:t>
+              <a:t>Historias de Usuarios</a:t>
             </a:r>
             <a:endParaRPr lang="es-ES" sz="3200" dirty="0">
               <a:solidFill>
                 <a:schemeClr val="bg1"/>
               </a:solidFill>
-            </a:endParaRPr>
-          </a:p>
-        </p:txBody>
-      </p:sp>
-      <p:sp>
-        <p:nvSpPr>
-          <p:cNvPr id="3" name="2 Marcador de contenido"/>
-          <p:cNvSpPr>
-            <a:spLocks noGrp="1"/>
-          </p:cNvSpPr>
-          <p:nvPr>
-            <p:ph idx="1"/>
-          </p:nvPr>
-        </p:nvSpPr>
-        <p:spPr>
-          <a:xfrm>
-            <a:off x="457200" y="1546201"/>
-            <a:ext cx="8363271" cy="4814186"/>
-          </a:xfrm>
-        </p:spPr>
-        <p:txBody>
-          <a:bodyPr>
-            <a:normAutofit/>
-          </a:bodyPr>
-          <a:lstStyle/>
-          <a:p>
-            <a:pPr marL="342900" lvl="0" indent="-342900" algn="just">
-              <a:lnSpc>
-                <a:spcPct val="115000"/>
-              </a:lnSpc>
-              <a:buFont typeface="Wingdings" panose="05000000000000000000" pitchFamily="2" charset="2"/>
-              <a:buChar char=""/>
-            </a:pPr>
-            <a:r>
-              <a:rPr lang="es-ES" sz="2400" dirty="0">
-                <a:solidFill>
-                  <a:srgbClr val="000000"/>
-                </a:solidFill>
-                <a:effectLst/>
-                <a:latin typeface="Arial" panose="020B0604020202020204" pitchFamily="34" charset="0"/>
-                <a:ea typeface="Calibri" panose="020F0502020204030204" pitchFamily="34" charset="0"/>
-              </a:rPr>
-              <a:t>HU_1: Autenticarse.</a:t>
-            </a:r>
-            <a:endParaRPr lang="es-CU" sz="2400" dirty="0">
-              <a:effectLst/>
-              <a:latin typeface="Arial" panose="020B0604020202020204" pitchFamily="34" charset="0"/>
-              <a:ea typeface="Calibri" panose="020F0502020204030204" pitchFamily="34" charset="0"/>
-            </a:endParaRPr>
-          </a:p>
-          <a:p>
-            <a:pPr marL="0" lvl="0" indent="0" algn="just">
-              <a:lnSpc>
-                <a:spcPct val="115000"/>
-              </a:lnSpc>
-              <a:buNone/>
-            </a:pPr>
-            <a:r>
-              <a:rPr lang="es-ES" sz="2400" dirty="0">
-                <a:solidFill>
-                  <a:srgbClr val="000000"/>
-                </a:solidFill>
-                <a:effectLst/>
-                <a:latin typeface="Arial" panose="020B0604020202020204" pitchFamily="34" charset="0"/>
-                <a:ea typeface="Calibri" panose="020F0502020204030204" pitchFamily="34" charset="0"/>
-              </a:rPr>
-              <a:t>.</a:t>
-            </a:r>
-            <a:endParaRPr lang="es-CU" sz="2400" dirty="0">
-              <a:effectLst/>
-              <a:latin typeface="Arial" panose="020B0604020202020204" pitchFamily="34" charset="0"/>
-              <a:ea typeface="Calibri" panose="020F0502020204030204" pitchFamily="34" charset="0"/>
             </a:endParaRPr>
           </a:p>
         </p:txBody>
@@ -10623,10 +9565,46 @@
           </a:p>
         </p:txBody>
       </p:sp>
+      <p:pic>
+        <p:nvPicPr>
+          <p:cNvPr id="15" name="Imagen 14" descr="Texto&#10;&#10;El contenido generado por IA puede ser incorrecto.">
+            <a:extLst>
+              <a:ext uri="{FF2B5EF4-FFF2-40B4-BE49-F238E27FC236}">
+                <a16:creationId xmlns:a16="http://schemas.microsoft.com/office/drawing/2014/main" id="{2A8C4AF2-7800-FAB2-FAD1-7C3421954A0D}"/>
+              </a:ext>
+            </a:extLst>
+          </p:cNvPr>
+          <p:cNvPicPr>
+            <a:picLocks noChangeAspect="1"/>
+          </p:cNvPicPr>
+          <p:nvPr/>
+        </p:nvPicPr>
+        <p:blipFill>
+          <a:blip r:embed="rId4">
+            <a:extLst>
+              <a:ext uri="{28A0092B-C50C-407E-A947-70E740481C1C}">
+                <a14:useLocalDpi xmlns:a14="http://schemas.microsoft.com/office/drawing/2010/main" val="0"/>
+              </a:ext>
+            </a:extLst>
+          </a:blip>
+          <a:stretch>
+            <a:fillRect/>
+          </a:stretch>
+        </p:blipFill>
+        <p:spPr>
+          <a:xfrm>
+            <a:off x="1304044" y="1242020"/>
+            <a:ext cx="6315956" cy="5172797"/>
+          </a:xfrm>
+          <a:prstGeom prst="rect">
+            <a:avLst/>
+          </a:prstGeom>
+        </p:spPr>
+      </p:pic>
     </p:spTree>
     <p:extLst>
       <p:ext uri="{BB962C8B-B14F-4D97-AF65-F5344CB8AC3E}">
-        <p14:creationId xmlns:p14="http://schemas.microsoft.com/office/powerpoint/2010/main" val="3787424618"/>
+        <p14:creationId xmlns:p14="http://schemas.microsoft.com/office/powerpoint/2010/main" val="1772699935"/>
       </p:ext>
     </p:extLst>
   </p:cSld>
@@ -10735,84 +9713,12 @@
                   <a:schemeClr val="bg1"/>
                 </a:solidFill>
               </a:rPr>
-              <a:t>Estructura del Directorio</a:t>
+              <a:t>Historias de Usuarios</a:t>
             </a:r>
             <a:endParaRPr lang="es-ES" sz="3200" dirty="0">
               <a:solidFill>
                 <a:schemeClr val="bg1"/>
               </a:solidFill>
-            </a:endParaRPr>
-          </a:p>
-        </p:txBody>
-      </p:sp>
-      <p:sp>
-        <p:nvSpPr>
-          <p:cNvPr id="3" name="2 Marcador de contenido"/>
-          <p:cNvSpPr>
-            <a:spLocks noGrp="1"/>
-          </p:cNvSpPr>
-          <p:nvPr>
-            <p:ph idx="1"/>
-          </p:nvPr>
-        </p:nvSpPr>
-        <p:spPr>
-          <a:xfrm>
-            <a:off x="457200" y="1546201"/>
-            <a:ext cx="8363271" cy="4814186"/>
-          </a:xfrm>
-        </p:spPr>
-        <p:txBody>
-          <a:bodyPr>
-            <a:normAutofit/>
-          </a:bodyPr>
-          <a:lstStyle/>
-          <a:p>
-            <a:pPr marL="342900" lvl="0" indent="-342900" algn="just">
-              <a:lnSpc>
-                <a:spcPct val="115000"/>
-              </a:lnSpc>
-              <a:buFont typeface="Wingdings" panose="05000000000000000000" pitchFamily="2" charset="2"/>
-              <a:buChar char=""/>
-            </a:pPr>
-            <a:r>
-              <a:rPr lang="es-ES" sz="2400" dirty="0">
-                <a:solidFill>
-                  <a:srgbClr val="000000"/>
-                </a:solidFill>
-                <a:effectLst/>
-                <a:latin typeface="Arial" panose="020B0604020202020204" pitchFamily="34" charset="0"/>
-                <a:ea typeface="Calibri" panose="020F0502020204030204" pitchFamily="34" charset="0"/>
-              </a:rPr>
-              <a:t>HU_1: Autenticarse.</a:t>
-            </a:r>
-            <a:endParaRPr lang="es-CU" sz="2400" dirty="0">
-              <a:effectLst/>
-              <a:latin typeface="Arial" panose="020B0604020202020204" pitchFamily="34" charset="0"/>
-              <a:ea typeface="Calibri" panose="020F0502020204030204" pitchFamily="34" charset="0"/>
-            </a:endParaRPr>
-          </a:p>
-          <a:p>
-            <a:pPr marL="0" lvl="0" indent="0" algn="just">
-              <a:lnSpc>
-                <a:spcPct val="115000"/>
-              </a:lnSpc>
-              <a:buNone/>
-            </a:pPr>
-            <a:r>
-              <a:rPr lang="es-ES" sz="2400" dirty="0">
-                <a:solidFill>
-                  <a:srgbClr val="000000"/>
-                </a:solidFill>
-                <a:effectLst/>
-                <a:latin typeface="Arial" panose="020B0604020202020204" pitchFamily="34" charset="0"/>
-                <a:ea typeface="Calibri" panose="020F0502020204030204" pitchFamily="34" charset="0"/>
-              </a:rPr>
-              <a:t>.</a:t>
-            </a:r>
-            <a:endParaRPr lang="es-CU" sz="2400" dirty="0">
-              <a:effectLst/>
-              <a:latin typeface="Arial" panose="020B0604020202020204" pitchFamily="34" charset="0"/>
-              <a:ea typeface="Calibri" panose="020F0502020204030204" pitchFamily="34" charset="0"/>
             </a:endParaRPr>
           </a:p>
         </p:txBody>
@@ -10869,10 +9775,46 @@
           </a:p>
         </p:txBody>
       </p:sp>
+      <p:pic>
+        <p:nvPicPr>
+          <p:cNvPr id="5" name="Imagen 4" descr="Texto, Escala de tiempo&#10;&#10;El contenido generado por IA puede ser incorrecto.">
+            <a:extLst>
+              <a:ext uri="{FF2B5EF4-FFF2-40B4-BE49-F238E27FC236}">
+                <a16:creationId xmlns:a16="http://schemas.microsoft.com/office/drawing/2014/main" id="{D78F4414-2F2B-2EF9-328B-2306E2297362}"/>
+              </a:ext>
+            </a:extLst>
+          </p:cNvPr>
+          <p:cNvPicPr>
+            <a:picLocks noChangeAspect="1"/>
+          </p:cNvPicPr>
+          <p:nvPr/>
+        </p:nvPicPr>
+        <p:blipFill>
+          <a:blip r:embed="rId4">
+            <a:extLst>
+              <a:ext uri="{28A0092B-C50C-407E-A947-70E740481C1C}">
+                <a14:useLocalDpi xmlns:a14="http://schemas.microsoft.com/office/drawing/2010/main" val="0"/>
+              </a:ext>
+            </a:extLst>
+          </a:blip>
+          <a:stretch>
+            <a:fillRect/>
+          </a:stretch>
+        </p:blipFill>
+        <p:spPr>
+          <a:xfrm>
+            <a:off x="1409258" y="1237944"/>
+            <a:ext cx="6325483" cy="5118406"/>
+          </a:xfrm>
+          <a:prstGeom prst="rect">
+            <a:avLst/>
+          </a:prstGeom>
+        </p:spPr>
+      </p:pic>
     </p:spTree>
     <p:extLst>
       <p:ext uri="{BB962C8B-B14F-4D97-AF65-F5344CB8AC3E}">
-        <p14:creationId xmlns:p14="http://schemas.microsoft.com/office/powerpoint/2010/main" val="426018444"/>
+        <p14:creationId xmlns:p14="http://schemas.microsoft.com/office/powerpoint/2010/main" val="2692848511"/>
       </p:ext>
     </p:extLst>
   </p:cSld>
@@ -10981,84 +9923,12 @@
                   <a:schemeClr val="bg1"/>
                 </a:solidFill>
               </a:rPr>
-              <a:t>Validaciones</a:t>
+              <a:t>Historias de Usuarios</a:t>
             </a:r>
             <a:endParaRPr lang="es-ES" sz="3200" dirty="0">
               <a:solidFill>
                 <a:schemeClr val="bg1"/>
               </a:solidFill>
-            </a:endParaRPr>
-          </a:p>
-        </p:txBody>
-      </p:sp>
-      <p:sp>
-        <p:nvSpPr>
-          <p:cNvPr id="3" name="2 Marcador de contenido"/>
-          <p:cNvSpPr>
-            <a:spLocks noGrp="1"/>
-          </p:cNvSpPr>
-          <p:nvPr>
-            <p:ph idx="1"/>
-          </p:nvPr>
-        </p:nvSpPr>
-        <p:spPr>
-          <a:xfrm>
-            <a:off x="457200" y="1546201"/>
-            <a:ext cx="8363271" cy="4814186"/>
-          </a:xfrm>
-        </p:spPr>
-        <p:txBody>
-          <a:bodyPr>
-            <a:normAutofit/>
-          </a:bodyPr>
-          <a:lstStyle/>
-          <a:p>
-            <a:pPr marL="342900" lvl="0" indent="-342900" algn="just">
-              <a:lnSpc>
-                <a:spcPct val="115000"/>
-              </a:lnSpc>
-              <a:buFont typeface="Wingdings" panose="05000000000000000000" pitchFamily="2" charset="2"/>
-              <a:buChar char=""/>
-            </a:pPr>
-            <a:r>
-              <a:rPr lang="es-ES" sz="2400" dirty="0">
-                <a:solidFill>
-                  <a:srgbClr val="000000"/>
-                </a:solidFill>
-                <a:effectLst/>
-                <a:latin typeface="Arial" panose="020B0604020202020204" pitchFamily="34" charset="0"/>
-                <a:ea typeface="Calibri" panose="020F0502020204030204" pitchFamily="34" charset="0"/>
-              </a:rPr>
-              <a:t>HU_1: Autenticarse.</a:t>
-            </a:r>
-            <a:endParaRPr lang="es-CU" sz="2400" dirty="0">
-              <a:effectLst/>
-              <a:latin typeface="Arial" panose="020B0604020202020204" pitchFamily="34" charset="0"/>
-              <a:ea typeface="Calibri" panose="020F0502020204030204" pitchFamily="34" charset="0"/>
-            </a:endParaRPr>
-          </a:p>
-          <a:p>
-            <a:pPr marL="0" lvl="0" indent="0" algn="just">
-              <a:lnSpc>
-                <a:spcPct val="115000"/>
-              </a:lnSpc>
-              <a:buNone/>
-            </a:pPr>
-            <a:r>
-              <a:rPr lang="es-ES" sz="2400" dirty="0">
-                <a:solidFill>
-                  <a:srgbClr val="000000"/>
-                </a:solidFill>
-                <a:effectLst/>
-                <a:latin typeface="Arial" panose="020B0604020202020204" pitchFamily="34" charset="0"/>
-                <a:ea typeface="Calibri" panose="020F0502020204030204" pitchFamily="34" charset="0"/>
-              </a:rPr>
-              <a:t>.</a:t>
-            </a:r>
-            <a:endParaRPr lang="es-CU" sz="2400" dirty="0">
-              <a:effectLst/>
-              <a:latin typeface="Arial" panose="020B0604020202020204" pitchFamily="34" charset="0"/>
-              <a:ea typeface="Calibri" panose="020F0502020204030204" pitchFamily="34" charset="0"/>
             </a:endParaRPr>
           </a:p>
         </p:txBody>
@@ -11115,10 +9985,76 @@
           </a:p>
         </p:txBody>
       </p:sp>
+      <p:pic>
+        <p:nvPicPr>
+          <p:cNvPr id="5" name="Imagen 4" descr="Texto, Escala de tiempo&#10;&#10;El contenido generado por IA puede ser incorrecto.">
+            <a:extLst>
+              <a:ext uri="{FF2B5EF4-FFF2-40B4-BE49-F238E27FC236}">
+                <a16:creationId xmlns:a16="http://schemas.microsoft.com/office/drawing/2014/main" id="{D78F4414-2F2B-2EF9-328B-2306E2297362}"/>
+              </a:ext>
+            </a:extLst>
+          </p:cNvPr>
+          <p:cNvPicPr>
+            <a:picLocks noChangeAspect="1"/>
+          </p:cNvPicPr>
+          <p:nvPr/>
+        </p:nvPicPr>
+        <p:blipFill>
+          <a:blip r:embed="rId4">
+            <a:extLst>
+              <a:ext uri="{28A0092B-C50C-407E-A947-70E740481C1C}">
+                <a14:useLocalDpi xmlns:a14="http://schemas.microsoft.com/office/drawing/2010/main" val="0"/>
+              </a:ext>
+            </a:extLst>
+          </a:blip>
+          <a:stretch>
+            <a:fillRect/>
+          </a:stretch>
+        </p:blipFill>
+        <p:spPr>
+          <a:xfrm>
+            <a:off x="1409258" y="1237944"/>
+            <a:ext cx="6325483" cy="5118406"/>
+          </a:xfrm>
+          <a:prstGeom prst="rect">
+            <a:avLst/>
+          </a:prstGeom>
+        </p:spPr>
+      </p:pic>
+      <p:pic>
+        <p:nvPicPr>
+          <p:cNvPr id="8" name="Imagen 7">
+            <a:extLst>
+              <a:ext uri="{FF2B5EF4-FFF2-40B4-BE49-F238E27FC236}">
+                <a16:creationId xmlns:a16="http://schemas.microsoft.com/office/drawing/2014/main" id="{28E6CD89-0491-68F9-FB6C-666F04413AD1}"/>
+              </a:ext>
+            </a:extLst>
+          </p:cNvPr>
+          <p:cNvPicPr>
+            <a:picLocks noChangeAspect="1"/>
+          </p:cNvPicPr>
+          <p:nvPr/>
+        </p:nvPicPr>
+        <p:blipFill>
+          <a:blip r:embed="rId5"/>
+          <a:stretch>
+            <a:fillRect/>
+          </a:stretch>
+        </p:blipFill>
+        <p:spPr>
+          <a:xfrm>
+            <a:off x="1399732" y="1228418"/>
+            <a:ext cx="6344535" cy="4401164"/>
+          </a:xfrm>
+          <a:prstGeom prst="rect">
+            <a:avLst/>
+          </a:prstGeom>
+        </p:spPr>
+      </p:pic>
     </p:spTree>
     <p:extLst>
       <p:ext uri="{BB962C8B-B14F-4D97-AF65-F5344CB8AC3E}">
-        <p14:creationId xmlns:p14="http://schemas.microsoft.com/office/powerpoint/2010/main" val="31956804"/>
+        <p14:creationId xmlns:p14="http://schemas.microsoft.com/office/powerpoint/2010/main" val="1680482545"/>
       </p:ext>
     </p:extLst>
   </p:cSld>
@@ -11504,7 +10440,7 @@
                   <a:schemeClr val="bg1"/>
                 </a:solidFill>
               </a:rPr>
-              <a:t>Pruebas de Aceptación</a:t>
+              <a:t>Arquitectura del Sistema</a:t>
             </a:r>
             <a:endParaRPr lang="es-ES" sz="3200" dirty="0">
               <a:solidFill>
@@ -11526,7 +10462,7 @@
         </p:nvSpPr>
         <p:spPr>
           <a:xfrm>
-            <a:off x="457200" y="1546201"/>
+            <a:off x="390364" y="1076393"/>
             <a:ext cx="8363271" cy="4814186"/>
           </a:xfrm>
         </p:spPr>
@@ -11536,52 +10472,147 @@
           </a:bodyPr>
           <a:lstStyle/>
           <a:p>
-            <a:pPr marL="342900" lvl="0" indent="-342900" algn="just">
-              <a:lnSpc>
-                <a:spcPct val="115000"/>
-              </a:lnSpc>
-              <a:buFont typeface="Wingdings" panose="05000000000000000000" pitchFamily="2" charset="2"/>
-              <a:buChar char=""/>
-            </a:pPr>
-            <a:r>
-              <a:rPr lang="es-ES" sz="2400" dirty="0">
-                <a:solidFill>
-                  <a:srgbClr val="000000"/>
-                </a:solidFill>
-                <a:effectLst/>
-                <a:latin typeface="Arial" panose="020B0604020202020204" pitchFamily="34" charset="0"/>
-                <a:ea typeface="Calibri" panose="020F0502020204030204" pitchFamily="34" charset="0"/>
-              </a:rPr>
-              <a:t>HU_1: Autenticarse.</a:t>
-            </a:r>
-            <a:endParaRPr lang="es-CU" sz="2400" dirty="0">
-              <a:effectLst/>
-              <a:latin typeface="Arial" panose="020B0604020202020204" pitchFamily="34" charset="0"/>
-              <a:ea typeface="Calibri" panose="020F0502020204030204" pitchFamily="34" charset="0"/>
-            </a:endParaRPr>
-          </a:p>
-          <a:p>
-            <a:pPr marL="0" lvl="0" indent="0" algn="just">
-              <a:lnSpc>
-                <a:spcPct val="115000"/>
-              </a:lnSpc>
+            <a:pPr marL="0" indent="0" algn="l">
               <a:buNone/>
             </a:pPr>
             <a:r>
-              <a:rPr lang="es-ES" sz="2400" dirty="0">
-                <a:solidFill>
-                  <a:srgbClr val="000000"/>
-                </a:solidFill>
+              <a:rPr lang="es-ES" sz="2400" b="1" i="0" dirty="0">
                 <a:effectLst/>
-                <a:latin typeface="Arial" panose="020B0604020202020204" pitchFamily="34" charset="0"/>
-                <a:ea typeface="Calibri" panose="020F0502020204030204" pitchFamily="34" charset="0"/>
+                <a:latin typeface="quote-cjk-patch"/>
+              </a:rPr>
+              <a:t>Modelo Vistas Controlador </a:t>
+            </a:r>
+            <a:r>
+              <a:rPr lang="es-ES" sz="2400" b="0" i="0" dirty="0">
+                <a:effectLst/>
+                <a:latin typeface="quote-cjk-patch"/>
+              </a:rPr>
+              <a:t> es un patrón de arquitectura de software que organiza una aplicación en tres componentes principales:</a:t>
+            </a:r>
+          </a:p>
+          <a:p>
+            <a:pPr algn="l">
+              <a:buFont typeface="+mj-lt"/>
+              <a:buAutoNum type="arabicPeriod"/>
+            </a:pPr>
+            <a:r>
+              <a:rPr lang="es-ES" sz="2400" b="1" i="0" dirty="0">
+                <a:effectLst/>
+                <a:latin typeface="quote-cjk-patch"/>
+              </a:rPr>
+              <a:t>Modelo</a:t>
+            </a:r>
+            <a:r>
+              <a:rPr lang="es-ES" sz="2400" b="0" i="0" dirty="0">
+                <a:effectLst/>
+                <a:latin typeface="quote-cjk-patch"/>
+              </a:rPr>
+              <a:t>: Gestiona los </a:t>
+            </a:r>
+            <a:r>
+              <a:rPr lang="es-ES" sz="2400" b="1" i="0" dirty="0">
+                <a:effectLst/>
+                <a:latin typeface="quote-cjk-patch"/>
+              </a:rPr>
+              <a:t>datos</a:t>
+            </a:r>
+            <a:r>
+              <a:rPr lang="es-ES" sz="2400" b="0" i="0" dirty="0">
+                <a:effectLst/>
+                <a:latin typeface="quote-cjk-patch"/>
+              </a:rPr>
+              <a:t> y la </a:t>
+            </a:r>
+            <a:r>
+              <a:rPr lang="es-ES" sz="2400" b="1" i="0" dirty="0">
+                <a:effectLst/>
+                <a:latin typeface="quote-cjk-patch"/>
+              </a:rPr>
+              <a:t>lógica de negocio</a:t>
+            </a:r>
+            <a:r>
+              <a:rPr lang="es-ES" sz="2400" b="0" i="0" dirty="0">
+                <a:effectLst/>
+                <a:latin typeface="quote-cjk-patch"/>
               </a:rPr>
               <a:t>.</a:t>
             </a:r>
-            <a:endParaRPr lang="es-CU" sz="2400" dirty="0">
+          </a:p>
+          <a:p>
+            <a:pPr algn="l">
+              <a:buFont typeface="+mj-lt"/>
+              <a:buAutoNum type="arabicPeriod"/>
+            </a:pPr>
+            <a:r>
+              <a:rPr lang="es-ES" sz="2400" b="1" i="0" dirty="0">
+                <a:effectLst/>
+                <a:latin typeface="quote-cjk-patch"/>
+              </a:rPr>
+              <a:t>Vista</a:t>
+            </a:r>
+            <a:r>
+              <a:rPr lang="es-ES" sz="2400" b="0" i="0" dirty="0">
+                <a:effectLst/>
+                <a:latin typeface="quote-cjk-patch"/>
+              </a:rPr>
+              <a:t>: Muestra la </a:t>
+            </a:r>
+            <a:r>
+              <a:rPr lang="es-ES" sz="2400" b="1" i="0" dirty="0">
+                <a:effectLst/>
+                <a:latin typeface="quote-cjk-patch"/>
+              </a:rPr>
+              <a:t>interfaz gráfica</a:t>
+            </a:r>
+            <a:r>
+              <a:rPr lang="es-ES" sz="2400" b="0" i="0" dirty="0">
+                <a:effectLst/>
+                <a:latin typeface="quote-cjk-patch"/>
+              </a:rPr>
+              <a:t> al usuario.</a:t>
+            </a:r>
+          </a:p>
+          <a:p>
+            <a:pPr algn="l">
+              <a:buFont typeface="+mj-lt"/>
+              <a:buAutoNum type="arabicPeriod"/>
+            </a:pPr>
+            <a:r>
+              <a:rPr lang="es-ES" sz="2400" b="1" i="0" dirty="0">
+                <a:effectLst/>
+                <a:latin typeface="quote-cjk-patch"/>
+              </a:rPr>
+              <a:t>Controlador</a:t>
+            </a:r>
+            <a:r>
+              <a:rPr lang="es-ES" sz="2400" b="0" i="0" dirty="0">
+                <a:effectLst/>
+                <a:latin typeface="quote-cjk-patch"/>
+              </a:rPr>
+              <a:t>: </a:t>
+            </a:r>
+            <a:r>
+              <a:rPr lang="es-ES" sz="2400" b="1" i="0" dirty="0">
+                <a:effectLst/>
+                <a:latin typeface="quote-cjk-patch"/>
+              </a:rPr>
+              <a:t>Intermedia</a:t>
+            </a:r>
+            <a:r>
+              <a:rPr lang="es-ES" sz="2400" b="0" i="0" dirty="0">
+                <a:effectLst/>
+                <a:latin typeface="quote-cjk-patch"/>
+              </a:rPr>
+              <a:t> entre el Modelo y la Vista.</a:t>
+            </a:r>
+          </a:p>
+          <a:p>
+            <a:pPr marL="457200" lvl="1" indent="0" algn="l">
+              <a:buNone/>
+            </a:pPr>
+            <a:endParaRPr lang="es-ES" b="0" i="0" dirty="0">
               <a:effectLst/>
-              <a:latin typeface="Arial" panose="020B0604020202020204" pitchFamily="34" charset="0"/>
-              <a:ea typeface="Calibri" panose="020F0502020204030204" pitchFamily="34" charset="0"/>
+              <a:latin typeface="quote-cjk-patch"/>
             </a:endParaRPr>
           </a:p>
         </p:txBody>
@@ -11638,10 +10669,57 @@
           </a:p>
         </p:txBody>
       </p:sp>
+      <p:pic>
+        <p:nvPicPr>
+          <p:cNvPr id="5" name="Imagen 4">
+            <a:extLst>
+              <a:ext uri="{FF2B5EF4-FFF2-40B4-BE49-F238E27FC236}">
+                <a16:creationId xmlns:a16="http://schemas.microsoft.com/office/drawing/2014/main" id="{2E831681-87F0-B726-C8CF-C25514B79E50}"/>
+              </a:ext>
+            </a:extLst>
+          </p:cNvPr>
+          <p:cNvPicPr>
+            <a:picLocks noChangeAspect="1"/>
+          </p:cNvPicPr>
+          <p:nvPr/>
+        </p:nvPicPr>
+        <p:blipFill>
+          <a:blip r:embed="rId4">
+            <a:extLst>
+              <a:ext uri="{28A0092B-C50C-407E-A947-70E740481C1C}">
+                <a14:useLocalDpi xmlns:a14="http://schemas.microsoft.com/office/drawing/2010/main" val="0"/>
+              </a:ext>
+            </a:extLst>
+          </a:blip>
+          <a:srcRect/>
+          <a:stretch>
+            <a:fillRect/>
+          </a:stretch>
+        </p:blipFill>
+        <p:spPr bwMode="auto">
+          <a:xfrm>
+            <a:off x="1172357" y="3717032"/>
+            <a:ext cx="6214822" cy="2832904"/>
+          </a:xfrm>
+          <a:prstGeom prst="rect">
+            <a:avLst/>
+          </a:prstGeom>
+          <a:noFill/>
+          <a:ln w="3175" cmpd="sng">
+            <a:solidFill>
+              <a:srgbClr val="000000"/>
+            </a:solidFill>
+            <a:miter lim="800000"/>
+            <a:headEnd/>
+            <a:tailEnd/>
+          </a:ln>
+          <a:effectLst/>
+        </p:spPr>
+      </p:pic>
     </p:spTree>
     <p:extLst>
       <p:ext uri="{BB962C8B-B14F-4D97-AF65-F5344CB8AC3E}">
-        <p14:creationId xmlns:p14="http://schemas.microsoft.com/office/powerpoint/2010/main" val="182701599"/>
+        <p14:creationId xmlns:p14="http://schemas.microsoft.com/office/powerpoint/2010/main" val="3787424618"/>
       </p:ext>
     </p:extLst>
   </p:cSld>
@@ -11750,84 +10828,12 @@
                   <a:schemeClr val="bg1"/>
                 </a:solidFill>
               </a:rPr>
-              <a:t>Interfaces Del Sistema</a:t>
+              <a:t>Estructura del Directorio</a:t>
             </a:r>
             <a:endParaRPr lang="es-ES" sz="3200" dirty="0">
               <a:solidFill>
                 <a:schemeClr val="bg1"/>
               </a:solidFill>
-            </a:endParaRPr>
-          </a:p>
-        </p:txBody>
-      </p:sp>
-      <p:sp>
-        <p:nvSpPr>
-          <p:cNvPr id="3" name="2 Marcador de contenido"/>
-          <p:cNvSpPr>
-            <a:spLocks noGrp="1"/>
-          </p:cNvSpPr>
-          <p:nvPr>
-            <p:ph idx="1"/>
-          </p:nvPr>
-        </p:nvSpPr>
-        <p:spPr>
-          <a:xfrm>
-            <a:off x="457200" y="1546201"/>
-            <a:ext cx="8363271" cy="4814186"/>
-          </a:xfrm>
-        </p:spPr>
-        <p:txBody>
-          <a:bodyPr>
-            <a:normAutofit/>
-          </a:bodyPr>
-          <a:lstStyle/>
-          <a:p>
-            <a:pPr marL="342900" lvl="0" indent="-342900" algn="just">
-              <a:lnSpc>
-                <a:spcPct val="115000"/>
-              </a:lnSpc>
-              <a:buFont typeface="Wingdings" panose="05000000000000000000" pitchFamily="2" charset="2"/>
-              <a:buChar char=""/>
-            </a:pPr>
-            <a:r>
-              <a:rPr lang="es-ES" sz="2400" dirty="0">
-                <a:solidFill>
-                  <a:srgbClr val="000000"/>
-                </a:solidFill>
-                <a:effectLst/>
-                <a:latin typeface="Arial" panose="020B0604020202020204" pitchFamily="34" charset="0"/>
-                <a:ea typeface="Calibri" panose="020F0502020204030204" pitchFamily="34" charset="0"/>
-              </a:rPr>
-              <a:t>HU_1: Autenticarse.</a:t>
-            </a:r>
-            <a:endParaRPr lang="es-CU" sz="2400" dirty="0">
-              <a:effectLst/>
-              <a:latin typeface="Arial" panose="020B0604020202020204" pitchFamily="34" charset="0"/>
-              <a:ea typeface="Calibri" panose="020F0502020204030204" pitchFamily="34" charset="0"/>
-            </a:endParaRPr>
-          </a:p>
-          <a:p>
-            <a:pPr marL="0" lvl="0" indent="0" algn="just">
-              <a:lnSpc>
-                <a:spcPct val="115000"/>
-              </a:lnSpc>
-              <a:buNone/>
-            </a:pPr>
-            <a:r>
-              <a:rPr lang="es-ES" sz="2400" dirty="0">
-                <a:solidFill>
-                  <a:srgbClr val="000000"/>
-                </a:solidFill>
-                <a:effectLst/>
-                <a:latin typeface="Arial" panose="020B0604020202020204" pitchFamily="34" charset="0"/>
-                <a:ea typeface="Calibri" panose="020F0502020204030204" pitchFamily="34" charset="0"/>
-              </a:rPr>
-              <a:t>.</a:t>
-            </a:r>
-            <a:endParaRPr lang="es-CU" sz="2400" dirty="0">
-              <a:effectLst/>
-              <a:latin typeface="Arial" panose="020B0604020202020204" pitchFamily="34" charset="0"/>
-              <a:ea typeface="Calibri" panose="020F0502020204030204" pitchFamily="34" charset="0"/>
             </a:endParaRPr>
           </a:p>
         </p:txBody>
@@ -11884,10 +10890,1148 @@
           </a:p>
         </p:txBody>
       </p:sp>
+      <p:pic>
+        <p:nvPicPr>
+          <p:cNvPr id="5" name="Imagen 4">
+            <a:extLst>
+              <a:ext uri="{FF2B5EF4-FFF2-40B4-BE49-F238E27FC236}">
+                <a16:creationId xmlns:a16="http://schemas.microsoft.com/office/drawing/2014/main" id="{CB235F8B-1B77-E086-44F9-FAE61B9272E0}"/>
+              </a:ext>
+            </a:extLst>
+          </p:cNvPr>
+          <p:cNvPicPr>
+            <a:picLocks noChangeAspect="1"/>
+          </p:cNvPicPr>
+          <p:nvPr/>
+        </p:nvPicPr>
+        <p:blipFill>
+          <a:blip r:embed="rId4">
+            <a:extLst>
+              <a:ext uri="{28A0092B-C50C-407E-A947-70E740481C1C}">
+                <a14:useLocalDpi xmlns:a14="http://schemas.microsoft.com/office/drawing/2010/main" val="0"/>
+              </a:ext>
+            </a:extLst>
+          </a:blip>
+          <a:srcRect/>
+          <a:stretch>
+            <a:fillRect/>
+          </a:stretch>
+        </p:blipFill>
+        <p:spPr bwMode="auto">
+          <a:xfrm>
+            <a:off x="384049" y="1772816"/>
+            <a:ext cx="4043935" cy="4255770"/>
+          </a:xfrm>
+          <a:prstGeom prst="rect">
+            <a:avLst/>
+          </a:prstGeom>
+          <a:noFill/>
+          <a:ln>
+            <a:noFill/>
+          </a:ln>
+        </p:spPr>
+      </p:pic>
+      <p:pic>
+        <p:nvPicPr>
+          <p:cNvPr id="11" name="Imagen 10" descr="Interfaz de usuario gráfica, Texto&#10;&#10;El contenido generado por IA puede ser incorrecto.">
+            <a:extLst>
+              <a:ext uri="{FF2B5EF4-FFF2-40B4-BE49-F238E27FC236}">
+                <a16:creationId xmlns:a16="http://schemas.microsoft.com/office/drawing/2014/main" id="{F5C82691-3D07-2D53-860D-36545429052C}"/>
+              </a:ext>
+            </a:extLst>
+          </p:cNvPr>
+          <p:cNvPicPr>
+            <a:picLocks noChangeAspect="1"/>
+          </p:cNvPicPr>
+          <p:nvPr/>
+        </p:nvPicPr>
+        <p:blipFill>
+          <a:blip r:embed="rId5">
+            <a:extLst>
+              <a:ext uri="{28A0092B-C50C-407E-A947-70E740481C1C}">
+                <a14:useLocalDpi xmlns:a14="http://schemas.microsoft.com/office/drawing/2010/main" val="0"/>
+              </a:ext>
+            </a:extLst>
+          </a:blip>
+          <a:stretch>
+            <a:fillRect/>
+          </a:stretch>
+        </p:blipFill>
+        <p:spPr>
+          <a:xfrm>
+            <a:off x="5379821" y="1011463"/>
+            <a:ext cx="2259229" cy="5803312"/>
+          </a:xfrm>
+          <a:prstGeom prst="rect">
+            <a:avLst/>
+          </a:prstGeom>
+        </p:spPr>
+      </p:pic>
+    </p:spTree>
+    <p:extLst>
+      <p:ext uri="{BB962C8B-B14F-4D97-AF65-F5344CB8AC3E}">
+        <p14:creationId xmlns:p14="http://schemas.microsoft.com/office/powerpoint/2010/main" val="426018444"/>
+      </p:ext>
+    </p:extLst>
+  </p:cSld>
+  <p:clrMapOvr>
+    <a:masterClrMapping/>
+  </p:clrMapOvr>
+</p:sld>
+</file>
+
+<file path=ppt/slides/slide22.xml><?xml version="1.0" encoding="utf-8"?>
+<p:sld xmlns:a="http://schemas.openxmlformats.org/drawingml/2006/main" xmlns:r="http://schemas.openxmlformats.org/officeDocument/2006/relationships" xmlns:p="http://schemas.openxmlformats.org/presentationml/2006/main">
+  <p:cSld>
+    <p:spTree>
+      <p:nvGrpSpPr>
+        <p:cNvPr id="1" name=""/>
+        <p:cNvGrpSpPr/>
+        <p:nvPr/>
+      </p:nvGrpSpPr>
+      <p:grpSpPr>
+        <a:xfrm>
+          <a:off x="0" y="0"/>
+          <a:ext cx="0" cy="0"/>
+          <a:chOff x="0" y="0"/>
+          <a:chExt cx="0" cy="0"/>
+        </a:xfrm>
+      </p:grpSpPr>
+      <p:pic>
+        <p:nvPicPr>
+          <p:cNvPr id="2051" name="Picture 3"/>
+          <p:cNvPicPr>
+            <a:picLocks noChangeAspect="1" noChangeArrowheads="1"/>
+          </p:cNvPicPr>
+          <p:nvPr/>
+        </p:nvPicPr>
+        <p:blipFill>
+          <a:blip r:embed="rId2">
+            <a:extLst>
+              <a:ext uri="{28A0092B-C50C-407E-A947-70E740481C1C}">
+                <a14:useLocalDpi xmlns:a14="http://schemas.microsoft.com/office/drawing/2010/main" val="0"/>
+              </a:ext>
+            </a:extLst>
+          </a:blip>
+          <a:srcRect/>
+          <a:stretch>
+            <a:fillRect/>
+          </a:stretch>
+        </p:blipFill>
+        <p:spPr bwMode="auto">
+          <a:xfrm>
+            <a:off x="1475657" y="0"/>
+            <a:ext cx="7668344" cy="1011462"/>
+          </a:xfrm>
+          <a:prstGeom prst="rect">
+            <a:avLst/>
+          </a:prstGeom>
+          <a:noFill/>
+          <a:ln>
+            <a:noFill/>
+          </a:ln>
+          <a:extLst>
+            <a:ext uri="{909E8E84-426E-40DD-AFC4-6F175D3DCCD1}">
+              <a14:hiddenFill xmlns:a14="http://schemas.microsoft.com/office/drawing/2010/main">
+                <a:solidFill>
+                  <a:schemeClr val="accent1"/>
+                </a:solidFill>
+              </a14:hiddenFill>
+            </a:ext>
+            <a:ext uri="{91240B29-F687-4F45-9708-019B960494DF}">
+              <a14:hiddenLine xmlns:a14="http://schemas.microsoft.com/office/drawing/2010/main" w="9525">
+                <a:solidFill>
+                  <a:schemeClr val="tx1"/>
+                </a:solidFill>
+                <a:miter lim="800000"/>
+                <a:headEnd/>
+                <a:tailEnd/>
+              </a14:hiddenLine>
+            </a:ext>
+          </a:extLst>
+        </p:spPr>
+      </p:pic>
+      <p:sp>
+        <p:nvSpPr>
+          <p:cNvPr id="2" name="1 Título"/>
+          <p:cNvSpPr>
+            <a:spLocks noGrp="1"/>
+          </p:cNvSpPr>
+          <p:nvPr>
+            <p:ph type="title"/>
+          </p:nvPr>
+        </p:nvSpPr>
+        <p:spPr>
+          <a:xfrm>
+            <a:off x="2555776" y="-66607"/>
+            <a:ext cx="5410944" cy="1143000"/>
+          </a:xfrm>
+        </p:spPr>
+        <p:txBody>
+          <a:bodyPr>
+            <a:normAutofit/>
+          </a:bodyPr>
+          <a:lstStyle/>
+          <a:p>
+            <a:r>
+              <a:rPr lang="es-ES" sz="3200" b="1" dirty="0">
+                <a:solidFill>
+                  <a:schemeClr val="bg1"/>
+                </a:solidFill>
+              </a:rPr>
+              <a:t>Validaciones</a:t>
+            </a:r>
+            <a:endParaRPr lang="es-ES" sz="3200" dirty="0">
+              <a:solidFill>
+                <a:schemeClr val="bg1"/>
+              </a:solidFill>
+            </a:endParaRPr>
+          </a:p>
+        </p:txBody>
+      </p:sp>
+      <p:pic>
+        <p:nvPicPr>
+          <p:cNvPr id="6" name="Imagen 5"/>
+          <p:cNvPicPr>
+            <a:picLocks noChangeAspect="1"/>
+          </p:cNvPicPr>
+          <p:nvPr/>
+        </p:nvPicPr>
+        <p:blipFill rotWithShape="1">
+          <a:blip r:embed="rId3" cstate="print">
+            <a:extLst>
+              <a:ext uri="{28A0092B-C50C-407E-A947-70E740481C1C}">
+                <a14:useLocalDpi xmlns:a14="http://schemas.microsoft.com/office/drawing/2010/main" val="0"/>
+              </a:ext>
+            </a:extLst>
+          </a:blip>
+          <a:srcRect l="4235" t="5471" r="70358" b="63070"/>
+          <a:stretch/>
+        </p:blipFill>
+        <p:spPr>
+          <a:xfrm>
+            <a:off x="303249" y="0"/>
+            <a:ext cx="921475" cy="883080"/>
+          </a:xfrm>
+          <a:prstGeom prst="rect">
+            <a:avLst/>
+          </a:prstGeom>
+        </p:spPr>
+      </p:pic>
+      <p:sp>
+        <p:nvSpPr>
+          <p:cNvPr id="4" name="Marcador de número de diapositiva 3"/>
+          <p:cNvSpPr>
+            <a:spLocks noGrp="1"/>
+          </p:cNvSpPr>
+          <p:nvPr>
+            <p:ph type="sldNum" sz="quarter" idx="12"/>
+          </p:nvPr>
+        </p:nvSpPr>
+        <p:spPr/>
+        <p:txBody>
+          <a:bodyPr/>
+          <a:lstStyle/>
+          <a:p>
+            <a:fld id="{132FADFE-3B8F-471C-ABF0-DBC7717ECBBC}" type="slidenum">
+              <a:rPr lang="es-ES" smtClean="0"/>
+              <a:t>22</a:t>
+            </a:fld>
+            <a:endParaRPr lang="es-ES"/>
+          </a:p>
+        </p:txBody>
+      </p:sp>
+      <p:pic>
+        <p:nvPicPr>
+          <p:cNvPr id="8" name="Marcador de contenido 7">
+            <a:extLst>
+              <a:ext uri="{FF2B5EF4-FFF2-40B4-BE49-F238E27FC236}">
+                <a16:creationId xmlns:a16="http://schemas.microsoft.com/office/drawing/2014/main" id="{F3EC616C-FEDA-00A5-896C-2004ADB79A4F}"/>
+              </a:ext>
+            </a:extLst>
+          </p:cNvPr>
+          <p:cNvPicPr>
+            <a:picLocks noGrp="1" noChangeAspect="1"/>
+          </p:cNvPicPr>
+          <p:nvPr>
+            <p:ph idx="1"/>
+          </p:nvPr>
+        </p:nvPicPr>
+        <p:blipFill>
+          <a:blip r:embed="rId4">
+            <a:extLst>
+              <a:ext uri="{28A0092B-C50C-407E-A947-70E740481C1C}">
+                <a14:useLocalDpi xmlns:a14="http://schemas.microsoft.com/office/drawing/2010/main" val="0"/>
+              </a:ext>
+            </a:extLst>
+          </a:blip>
+          <a:srcRect/>
+          <a:stretch>
+            <a:fillRect/>
+          </a:stretch>
+        </p:blipFill>
+        <p:spPr bwMode="auto">
+          <a:xfrm>
+            <a:off x="945263" y="1600200"/>
+            <a:ext cx="7253473" cy="4525963"/>
+          </a:xfrm>
+          <a:prstGeom prst="rect">
+            <a:avLst/>
+          </a:prstGeom>
+          <a:noFill/>
+          <a:ln>
+            <a:noFill/>
+          </a:ln>
+        </p:spPr>
+      </p:pic>
+    </p:spTree>
+    <p:extLst>
+      <p:ext uri="{BB962C8B-B14F-4D97-AF65-F5344CB8AC3E}">
+        <p14:creationId xmlns:p14="http://schemas.microsoft.com/office/powerpoint/2010/main" val="31956804"/>
+      </p:ext>
+    </p:extLst>
+  </p:cSld>
+  <p:clrMapOvr>
+    <a:masterClrMapping/>
+  </p:clrMapOvr>
+</p:sld>
+</file>
+
+<file path=ppt/slides/slide23.xml><?xml version="1.0" encoding="utf-8"?>
+<p:sld xmlns:a="http://schemas.openxmlformats.org/drawingml/2006/main" xmlns:r="http://schemas.openxmlformats.org/officeDocument/2006/relationships" xmlns:p="http://schemas.openxmlformats.org/presentationml/2006/main">
+  <p:cSld>
+    <p:spTree>
+      <p:nvGrpSpPr>
+        <p:cNvPr id="1" name=""/>
+        <p:cNvGrpSpPr/>
+        <p:nvPr/>
+      </p:nvGrpSpPr>
+      <p:grpSpPr>
+        <a:xfrm>
+          <a:off x="0" y="0"/>
+          <a:ext cx="0" cy="0"/>
+          <a:chOff x="0" y="0"/>
+          <a:chExt cx="0" cy="0"/>
+        </a:xfrm>
+      </p:grpSpPr>
+      <p:pic>
+        <p:nvPicPr>
+          <p:cNvPr id="2051" name="Picture 3"/>
+          <p:cNvPicPr>
+            <a:picLocks noChangeAspect="1" noChangeArrowheads="1"/>
+          </p:cNvPicPr>
+          <p:nvPr/>
+        </p:nvPicPr>
+        <p:blipFill>
+          <a:blip r:embed="rId2">
+            <a:extLst>
+              <a:ext uri="{28A0092B-C50C-407E-A947-70E740481C1C}">
+                <a14:useLocalDpi xmlns:a14="http://schemas.microsoft.com/office/drawing/2010/main" val="0"/>
+              </a:ext>
+            </a:extLst>
+          </a:blip>
+          <a:srcRect/>
+          <a:stretch>
+            <a:fillRect/>
+          </a:stretch>
+        </p:blipFill>
+        <p:spPr bwMode="auto">
+          <a:xfrm>
+            <a:off x="1475657" y="0"/>
+            <a:ext cx="7668344" cy="1011462"/>
+          </a:xfrm>
+          <a:prstGeom prst="rect">
+            <a:avLst/>
+          </a:prstGeom>
+          <a:noFill/>
+          <a:ln>
+            <a:noFill/>
+          </a:ln>
+          <a:extLst>
+            <a:ext uri="{909E8E84-426E-40DD-AFC4-6F175D3DCCD1}">
+              <a14:hiddenFill xmlns:a14="http://schemas.microsoft.com/office/drawing/2010/main">
+                <a:solidFill>
+                  <a:schemeClr val="accent1"/>
+                </a:solidFill>
+              </a14:hiddenFill>
+            </a:ext>
+            <a:ext uri="{91240B29-F687-4F45-9708-019B960494DF}">
+              <a14:hiddenLine xmlns:a14="http://schemas.microsoft.com/office/drawing/2010/main" w="9525">
+                <a:solidFill>
+                  <a:schemeClr val="tx1"/>
+                </a:solidFill>
+                <a:miter lim="800000"/>
+                <a:headEnd/>
+                <a:tailEnd/>
+              </a14:hiddenLine>
+            </a:ext>
+          </a:extLst>
+        </p:spPr>
+      </p:pic>
+      <p:sp>
+        <p:nvSpPr>
+          <p:cNvPr id="2" name="1 Título"/>
+          <p:cNvSpPr>
+            <a:spLocks noGrp="1"/>
+          </p:cNvSpPr>
+          <p:nvPr>
+            <p:ph type="title"/>
+          </p:nvPr>
+        </p:nvSpPr>
+        <p:spPr>
+          <a:xfrm>
+            <a:off x="2555776" y="-66607"/>
+            <a:ext cx="5410944" cy="1143000"/>
+          </a:xfrm>
+        </p:spPr>
+        <p:txBody>
+          <a:bodyPr>
+            <a:normAutofit/>
+          </a:bodyPr>
+          <a:lstStyle/>
+          <a:p>
+            <a:r>
+              <a:rPr lang="es-ES" sz="3200" b="1" dirty="0">
+                <a:solidFill>
+                  <a:schemeClr val="bg1"/>
+                </a:solidFill>
+              </a:rPr>
+              <a:t>Validaciones</a:t>
+            </a:r>
+            <a:endParaRPr lang="es-ES" sz="3200" dirty="0">
+              <a:solidFill>
+                <a:schemeClr val="bg1"/>
+              </a:solidFill>
+            </a:endParaRPr>
+          </a:p>
+        </p:txBody>
+      </p:sp>
+      <p:pic>
+        <p:nvPicPr>
+          <p:cNvPr id="6" name="Imagen 5"/>
+          <p:cNvPicPr>
+            <a:picLocks noChangeAspect="1"/>
+          </p:cNvPicPr>
+          <p:nvPr/>
+        </p:nvPicPr>
+        <p:blipFill rotWithShape="1">
+          <a:blip r:embed="rId3" cstate="print">
+            <a:extLst>
+              <a:ext uri="{28A0092B-C50C-407E-A947-70E740481C1C}">
+                <a14:useLocalDpi xmlns:a14="http://schemas.microsoft.com/office/drawing/2010/main" val="0"/>
+              </a:ext>
+            </a:extLst>
+          </a:blip>
+          <a:srcRect l="4235" t="5471" r="70358" b="63070"/>
+          <a:stretch/>
+        </p:blipFill>
+        <p:spPr>
+          <a:xfrm>
+            <a:off x="303249" y="0"/>
+            <a:ext cx="921475" cy="883080"/>
+          </a:xfrm>
+          <a:prstGeom prst="rect">
+            <a:avLst/>
+          </a:prstGeom>
+        </p:spPr>
+      </p:pic>
+      <p:sp>
+        <p:nvSpPr>
+          <p:cNvPr id="4" name="Marcador de número de diapositiva 3"/>
+          <p:cNvSpPr>
+            <a:spLocks noGrp="1"/>
+          </p:cNvSpPr>
+          <p:nvPr>
+            <p:ph type="sldNum" sz="quarter" idx="12"/>
+          </p:nvPr>
+        </p:nvSpPr>
+        <p:spPr/>
+        <p:txBody>
+          <a:bodyPr/>
+          <a:lstStyle/>
+          <a:p>
+            <a:fld id="{132FADFE-3B8F-471C-ABF0-DBC7717ECBBC}" type="slidenum">
+              <a:rPr lang="es-ES" smtClean="0"/>
+              <a:t>23</a:t>
+            </a:fld>
+            <a:endParaRPr lang="es-ES"/>
+          </a:p>
+        </p:txBody>
+      </p:sp>
+      <p:pic>
+        <p:nvPicPr>
+          <p:cNvPr id="7" name="Imagen 6">
+            <a:extLst>
+              <a:ext uri="{FF2B5EF4-FFF2-40B4-BE49-F238E27FC236}">
+                <a16:creationId xmlns:a16="http://schemas.microsoft.com/office/drawing/2014/main" id="{58AB41B2-D528-5AF1-DCF4-B9E579275F3E}"/>
+              </a:ext>
+            </a:extLst>
+          </p:cNvPr>
+          <p:cNvPicPr>
+            <a:picLocks noChangeAspect="1"/>
+          </p:cNvPicPr>
+          <p:nvPr/>
+        </p:nvPicPr>
+        <p:blipFill>
+          <a:blip r:embed="rId4">
+            <a:extLst>
+              <a:ext uri="{28A0092B-C50C-407E-A947-70E740481C1C}">
+                <a14:useLocalDpi xmlns:a14="http://schemas.microsoft.com/office/drawing/2010/main" val="0"/>
+              </a:ext>
+            </a:extLst>
+          </a:blip>
+          <a:srcRect/>
+          <a:stretch>
+            <a:fillRect/>
+          </a:stretch>
+        </p:blipFill>
+        <p:spPr bwMode="auto">
+          <a:xfrm>
+            <a:off x="303249" y="2137941"/>
+            <a:ext cx="8595513" cy="3416411"/>
+          </a:xfrm>
+          <a:prstGeom prst="rect">
+            <a:avLst/>
+          </a:prstGeom>
+          <a:noFill/>
+          <a:ln>
+            <a:noFill/>
+          </a:ln>
+        </p:spPr>
+      </p:pic>
+    </p:spTree>
+    <p:extLst>
+      <p:ext uri="{BB962C8B-B14F-4D97-AF65-F5344CB8AC3E}">
+        <p14:creationId xmlns:p14="http://schemas.microsoft.com/office/powerpoint/2010/main" val="1299837795"/>
+      </p:ext>
+    </p:extLst>
+  </p:cSld>
+  <p:clrMapOvr>
+    <a:masterClrMapping/>
+  </p:clrMapOvr>
+</p:sld>
+</file>
+
+<file path=ppt/slides/slide24.xml><?xml version="1.0" encoding="utf-8"?>
+<p:sld xmlns:a="http://schemas.openxmlformats.org/drawingml/2006/main" xmlns:r="http://schemas.openxmlformats.org/officeDocument/2006/relationships" xmlns:p="http://schemas.openxmlformats.org/presentationml/2006/main">
+  <p:cSld>
+    <p:spTree>
+      <p:nvGrpSpPr>
+        <p:cNvPr id="1" name=""/>
+        <p:cNvGrpSpPr/>
+        <p:nvPr/>
+      </p:nvGrpSpPr>
+      <p:grpSpPr>
+        <a:xfrm>
+          <a:off x="0" y="0"/>
+          <a:ext cx="0" cy="0"/>
+          <a:chOff x="0" y="0"/>
+          <a:chExt cx="0" cy="0"/>
+        </a:xfrm>
+      </p:grpSpPr>
+      <p:pic>
+        <p:nvPicPr>
+          <p:cNvPr id="2051" name="Picture 3"/>
+          <p:cNvPicPr>
+            <a:picLocks noChangeAspect="1" noChangeArrowheads="1"/>
+          </p:cNvPicPr>
+          <p:nvPr/>
+        </p:nvPicPr>
+        <p:blipFill>
+          <a:blip r:embed="rId2">
+            <a:extLst>
+              <a:ext uri="{28A0092B-C50C-407E-A947-70E740481C1C}">
+                <a14:useLocalDpi xmlns:a14="http://schemas.microsoft.com/office/drawing/2010/main" val="0"/>
+              </a:ext>
+            </a:extLst>
+          </a:blip>
+          <a:srcRect/>
+          <a:stretch>
+            <a:fillRect/>
+          </a:stretch>
+        </p:blipFill>
+        <p:spPr bwMode="auto">
+          <a:xfrm>
+            <a:off x="1475657" y="0"/>
+            <a:ext cx="7668344" cy="1011462"/>
+          </a:xfrm>
+          <a:prstGeom prst="rect">
+            <a:avLst/>
+          </a:prstGeom>
+          <a:noFill/>
+          <a:ln>
+            <a:noFill/>
+          </a:ln>
+          <a:extLst>
+            <a:ext uri="{909E8E84-426E-40DD-AFC4-6F175D3DCCD1}">
+              <a14:hiddenFill xmlns:a14="http://schemas.microsoft.com/office/drawing/2010/main">
+                <a:solidFill>
+                  <a:schemeClr val="accent1"/>
+                </a:solidFill>
+              </a14:hiddenFill>
+            </a:ext>
+            <a:ext uri="{91240B29-F687-4F45-9708-019B960494DF}">
+              <a14:hiddenLine xmlns:a14="http://schemas.microsoft.com/office/drawing/2010/main" w="9525">
+                <a:solidFill>
+                  <a:schemeClr val="tx1"/>
+                </a:solidFill>
+                <a:miter lim="800000"/>
+                <a:headEnd/>
+                <a:tailEnd/>
+              </a14:hiddenLine>
+            </a:ext>
+          </a:extLst>
+        </p:spPr>
+      </p:pic>
+      <p:sp>
+        <p:nvSpPr>
+          <p:cNvPr id="2" name="1 Título"/>
+          <p:cNvSpPr>
+            <a:spLocks noGrp="1"/>
+          </p:cNvSpPr>
+          <p:nvPr>
+            <p:ph type="title"/>
+          </p:nvPr>
+        </p:nvSpPr>
+        <p:spPr>
+          <a:xfrm>
+            <a:off x="2555776" y="-66607"/>
+            <a:ext cx="5410944" cy="1143000"/>
+          </a:xfrm>
+        </p:spPr>
+        <p:txBody>
+          <a:bodyPr>
+            <a:normAutofit/>
+          </a:bodyPr>
+          <a:lstStyle/>
+          <a:p>
+            <a:r>
+              <a:rPr lang="es-ES" sz="3200" b="1" dirty="0">
+                <a:solidFill>
+                  <a:schemeClr val="bg1"/>
+                </a:solidFill>
+              </a:rPr>
+              <a:t>Pruebas de Aceptación</a:t>
+            </a:r>
+            <a:endParaRPr lang="es-ES" sz="3200" dirty="0">
+              <a:solidFill>
+                <a:schemeClr val="bg1"/>
+              </a:solidFill>
+            </a:endParaRPr>
+          </a:p>
+        </p:txBody>
+      </p:sp>
+      <p:pic>
+        <p:nvPicPr>
+          <p:cNvPr id="6" name="Imagen 5"/>
+          <p:cNvPicPr>
+            <a:picLocks noChangeAspect="1"/>
+          </p:cNvPicPr>
+          <p:nvPr/>
+        </p:nvPicPr>
+        <p:blipFill rotWithShape="1">
+          <a:blip r:embed="rId3" cstate="print">
+            <a:extLst>
+              <a:ext uri="{28A0092B-C50C-407E-A947-70E740481C1C}">
+                <a14:useLocalDpi xmlns:a14="http://schemas.microsoft.com/office/drawing/2010/main" val="0"/>
+              </a:ext>
+            </a:extLst>
+          </a:blip>
+          <a:srcRect l="4235" t="5471" r="70358" b="63070"/>
+          <a:stretch/>
+        </p:blipFill>
+        <p:spPr>
+          <a:xfrm>
+            <a:off x="303249" y="0"/>
+            <a:ext cx="921475" cy="883080"/>
+          </a:xfrm>
+          <a:prstGeom prst="rect">
+            <a:avLst/>
+          </a:prstGeom>
+        </p:spPr>
+      </p:pic>
+      <p:sp>
+        <p:nvSpPr>
+          <p:cNvPr id="4" name="Marcador de número de diapositiva 3"/>
+          <p:cNvSpPr>
+            <a:spLocks noGrp="1"/>
+          </p:cNvSpPr>
+          <p:nvPr>
+            <p:ph type="sldNum" sz="quarter" idx="12"/>
+          </p:nvPr>
+        </p:nvSpPr>
+        <p:spPr/>
+        <p:txBody>
+          <a:bodyPr/>
+          <a:lstStyle/>
+          <a:p>
+            <a:fld id="{132FADFE-3B8F-471C-ABF0-DBC7717ECBBC}" type="slidenum">
+              <a:rPr lang="es-ES" smtClean="0"/>
+              <a:t>24</a:t>
+            </a:fld>
+            <a:endParaRPr lang="es-ES"/>
+          </a:p>
+        </p:txBody>
+      </p:sp>
+      <p:pic>
+        <p:nvPicPr>
+          <p:cNvPr id="9" name="Marcador de contenido 8" descr="Texto&#10;&#10;El contenido generado por IA puede ser incorrecto.">
+            <a:extLst>
+              <a:ext uri="{FF2B5EF4-FFF2-40B4-BE49-F238E27FC236}">
+                <a16:creationId xmlns:a16="http://schemas.microsoft.com/office/drawing/2014/main" id="{E4913D87-377B-A201-E583-844BABA23E83}"/>
+              </a:ext>
+            </a:extLst>
+          </p:cNvPr>
+          <p:cNvPicPr>
+            <a:picLocks noGrp="1" noChangeAspect="1"/>
+          </p:cNvPicPr>
+          <p:nvPr>
+            <p:ph idx="1"/>
+          </p:nvPr>
+        </p:nvPicPr>
+        <p:blipFill>
+          <a:blip r:embed="rId4">
+            <a:extLst>
+              <a:ext uri="{28A0092B-C50C-407E-A947-70E740481C1C}">
+                <a14:useLocalDpi xmlns:a14="http://schemas.microsoft.com/office/drawing/2010/main" val="0"/>
+              </a:ext>
+            </a:extLst>
+          </a:blip>
+          <a:stretch>
+            <a:fillRect/>
+          </a:stretch>
+        </p:blipFill>
+        <p:spPr>
+          <a:xfrm>
+            <a:off x="763986" y="1725972"/>
+            <a:ext cx="7761129" cy="3406056"/>
+          </a:xfrm>
+        </p:spPr>
+      </p:pic>
+    </p:spTree>
+    <p:extLst>
+      <p:ext uri="{BB962C8B-B14F-4D97-AF65-F5344CB8AC3E}">
+        <p14:creationId xmlns:p14="http://schemas.microsoft.com/office/powerpoint/2010/main" val="182701599"/>
+      </p:ext>
+    </p:extLst>
+  </p:cSld>
+  <p:clrMapOvr>
+    <a:masterClrMapping/>
+  </p:clrMapOvr>
+</p:sld>
+</file>
+
+<file path=ppt/slides/slide25.xml><?xml version="1.0" encoding="utf-8"?>
+<p:sld xmlns:a="http://schemas.openxmlformats.org/drawingml/2006/main" xmlns:r="http://schemas.openxmlformats.org/officeDocument/2006/relationships" xmlns:p="http://schemas.openxmlformats.org/presentationml/2006/main">
+  <p:cSld>
+    <p:spTree>
+      <p:nvGrpSpPr>
+        <p:cNvPr id="1" name=""/>
+        <p:cNvGrpSpPr/>
+        <p:nvPr/>
+      </p:nvGrpSpPr>
+      <p:grpSpPr>
+        <a:xfrm>
+          <a:off x="0" y="0"/>
+          <a:ext cx="0" cy="0"/>
+          <a:chOff x="0" y="0"/>
+          <a:chExt cx="0" cy="0"/>
+        </a:xfrm>
+      </p:grpSpPr>
+      <p:pic>
+        <p:nvPicPr>
+          <p:cNvPr id="2051" name="Picture 3"/>
+          <p:cNvPicPr>
+            <a:picLocks noChangeAspect="1" noChangeArrowheads="1"/>
+          </p:cNvPicPr>
+          <p:nvPr/>
+        </p:nvPicPr>
+        <p:blipFill>
+          <a:blip r:embed="rId2">
+            <a:extLst>
+              <a:ext uri="{28A0092B-C50C-407E-A947-70E740481C1C}">
+                <a14:useLocalDpi xmlns:a14="http://schemas.microsoft.com/office/drawing/2010/main" val="0"/>
+              </a:ext>
+            </a:extLst>
+          </a:blip>
+          <a:srcRect/>
+          <a:stretch>
+            <a:fillRect/>
+          </a:stretch>
+        </p:blipFill>
+        <p:spPr bwMode="auto">
+          <a:xfrm>
+            <a:off x="1475657" y="0"/>
+            <a:ext cx="7668344" cy="1011462"/>
+          </a:xfrm>
+          <a:prstGeom prst="rect">
+            <a:avLst/>
+          </a:prstGeom>
+          <a:noFill/>
+          <a:ln>
+            <a:noFill/>
+          </a:ln>
+          <a:extLst>
+            <a:ext uri="{909E8E84-426E-40DD-AFC4-6F175D3DCCD1}">
+              <a14:hiddenFill xmlns:a14="http://schemas.microsoft.com/office/drawing/2010/main">
+                <a:solidFill>
+                  <a:schemeClr val="accent1"/>
+                </a:solidFill>
+              </a14:hiddenFill>
+            </a:ext>
+            <a:ext uri="{91240B29-F687-4F45-9708-019B960494DF}">
+              <a14:hiddenLine xmlns:a14="http://schemas.microsoft.com/office/drawing/2010/main" w="9525">
+                <a:solidFill>
+                  <a:schemeClr val="tx1"/>
+                </a:solidFill>
+                <a:miter lim="800000"/>
+                <a:headEnd/>
+                <a:tailEnd/>
+              </a14:hiddenLine>
+            </a:ext>
+          </a:extLst>
+        </p:spPr>
+      </p:pic>
+      <p:sp>
+        <p:nvSpPr>
+          <p:cNvPr id="2" name="1 Título"/>
+          <p:cNvSpPr>
+            <a:spLocks noGrp="1"/>
+          </p:cNvSpPr>
+          <p:nvPr>
+            <p:ph type="title"/>
+          </p:nvPr>
+        </p:nvSpPr>
+        <p:spPr>
+          <a:xfrm>
+            <a:off x="2555776" y="-66607"/>
+            <a:ext cx="5410944" cy="1143000"/>
+          </a:xfrm>
+        </p:spPr>
+        <p:txBody>
+          <a:bodyPr>
+            <a:normAutofit/>
+          </a:bodyPr>
+          <a:lstStyle/>
+          <a:p>
+            <a:r>
+              <a:rPr lang="es-ES" sz="3200" b="1" dirty="0">
+                <a:solidFill>
+                  <a:schemeClr val="bg1"/>
+                </a:solidFill>
+              </a:rPr>
+              <a:t>Interfaces Del Sistema</a:t>
+            </a:r>
+            <a:endParaRPr lang="es-ES" sz="3200" dirty="0">
+              <a:solidFill>
+                <a:schemeClr val="bg1"/>
+              </a:solidFill>
+            </a:endParaRPr>
+          </a:p>
+        </p:txBody>
+      </p:sp>
+      <p:pic>
+        <p:nvPicPr>
+          <p:cNvPr id="6" name="Imagen 5"/>
+          <p:cNvPicPr>
+            <a:picLocks noChangeAspect="1"/>
+          </p:cNvPicPr>
+          <p:nvPr/>
+        </p:nvPicPr>
+        <p:blipFill rotWithShape="1">
+          <a:blip r:embed="rId3" cstate="print">
+            <a:extLst>
+              <a:ext uri="{28A0092B-C50C-407E-A947-70E740481C1C}">
+                <a14:useLocalDpi xmlns:a14="http://schemas.microsoft.com/office/drawing/2010/main" val="0"/>
+              </a:ext>
+            </a:extLst>
+          </a:blip>
+          <a:srcRect l="4235" t="5471" r="70358" b="63070"/>
+          <a:stretch/>
+        </p:blipFill>
+        <p:spPr>
+          <a:xfrm>
+            <a:off x="303249" y="0"/>
+            <a:ext cx="921475" cy="883080"/>
+          </a:xfrm>
+          <a:prstGeom prst="rect">
+            <a:avLst/>
+          </a:prstGeom>
+        </p:spPr>
+      </p:pic>
+      <p:sp>
+        <p:nvSpPr>
+          <p:cNvPr id="4" name="Marcador de número de diapositiva 3"/>
+          <p:cNvSpPr>
+            <a:spLocks noGrp="1"/>
+          </p:cNvSpPr>
+          <p:nvPr>
+            <p:ph type="sldNum" sz="quarter" idx="12"/>
+          </p:nvPr>
+        </p:nvSpPr>
+        <p:spPr/>
+        <p:txBody>
+          <a:bodyPr/>
+          <a:lstStyle/>
+          <a:p>
+            <a:fld id="{132FADFE-3B8F-471C-ABF0-DBC7717ECBBC}" type="slidenum">
+              <a:rPr lang="es-ES" smtClean="0"/>
+              <a:t>25</a:t>
+            </a:fld>
+            <a:endParaRPr lang="es-ES"/>
+          </a:p>
+        </p:txBody>
+      </p:sp>
+      <p:pic>
+        <p:nvPicPr>
+          <p:cNvPr id="9" name="Imagen 8" descr="Interfaz de usuario gráfica, Aplicación">
+            <a:extLst>
+              <a:ext uri="{FF2B5EF4-FFF2-40B4-BE49-F238E27FC236}">
+                <a16:creationId xmlns:a16="http://schemas.microsoft.com/office/drawing/2014/main" id="{BC6286B3-27DE-B7EF-F4C7-CE6A28723B7B}"/>
+              </a:ext>
+            </a:extLst>
+          </p:cNvPr>
+          <p:cNvPicPr>
+            <a:picLocks noChangeAspect="1"/>
+          </p:cNvPicPr>
+          <p:nvPr/>
+        </p:nvPicPr>
+        <p:blipFill>
+          <a:blip r:embed="rId4">
+            <a:extLst>
+              <a:ext uri="{28A0092B-C50C-407E-A947-70E740481C1C}">
+                <a14:useLocalDpi xmlns:a14="http://schemas.microsoft.com/office/drawing/2010/main" val="0"/>
+              </a:ext>
+            </a:extLst>
+          </a:blip>
+          <a:stretch>
+            <a:fillRect/>
+          </a:stretch>
+        </p:blipFill>
+        <p:spPr>
+          <a:xfrm>
+            <a:off x="0" y="2201527"/>
+            <a:ext cx="9112456" cy="3961510"/>
+          </a:xfrm>
+          <a:prstGeom prst="rect">
+            <a:avLst/>
+          </a:prstGeom>
+        </p:spPr>
+      </p:pic>
     </p:spTree>
     <p:extLst>
       <p:ext uri="{BB962C8B-B14F-4D97-AF65-F5344CB8AC3E}">
         <p14:creationId xmlns:p14="http://schemas.microsoft.com/office/powerpoint/2010/main" val="329657551"/>
+      </p:ext>
+    </p:extLst>
+  </p:cSld>
+  <p:clrMapOvr>
+    <a:masterClrMapping/>
+  </p:clrMapOvr>
+</p:sld>
+</file>
+
+<file path=ppt/slides/slide26.xml><?xml version="1.0" encoding="utf-8"?>
+<p:sld xmlns:a="http://schemas.openxmlformats.org/drawingml/2006/main" xmlns:r="http://schemas.openxmlformats.org/officeDocument/2006/relationships" xmlns:p="http://schemas.openxmlformats.org/presentationml/2006/main">
+  <p:cSld>
+    <p:spTree>
+      <p:nvGrpSpPr>
+        <p:cNvPr id="1" name=""/>
+        <p:cNvGrpSpPr/>
+        <p:nvPr/>
+      </p:nvGrpSpPr>
+      <p:grpSpPr>
+        <a:xfrm>
+          <a:off x="0" y="0"/>
+          <a:ext cx="0" cy="0"/>
+          <a:chOff x="0" y="0"/>
+          <a:chExt cx="0" cy="0"/>
+        </a:xfrm>
+      </p:grpSpPr>
+      <p:pic>
+        <p:nvPicPr>
+          <p:cNvPr id="2051" name="Picture 3"/>
+          <p:cNvPicPr>
+            <a:picLocks noChangeAspect="1" noChangeArrowheads="1"/>
+          </p:cNvPicPr>
+          <p:nvPr/>
+        </p:nvPicPr>
+        <p:blipFill>
+          <a:blip r:embed="rId2">
+            <a:extLst>
+              <a:ext uri="{28A0092B-C50C-407E-A947-70E740481C1C}">
+                <a14:useLocalDpi xmlns:a14="http://schemas.microsoft.com/office/drawing/2010/main" val="0"/>
+              </a:ext>
+            </a:extLst>
+          </a:blip>
+          <a:srcRect/>
+          <a:stretch>
+            <a:fillRect/>
+          </a:stretch>
+        </p:blipFill>
+        <p:spPr bwMode="auto">
+          <a:xfrm>
+            <a:off x="1475657" y="0"/>
+            <a:ext cx="7668344" cy="1011462"/>
+          </a:xfrm>
+          <a:prstGeom prst="rect">
+            <a:avLst/>
+          </a:prstGeom>
+          <a:noFill/>
+          <a:ln>
+            <a:noFill/>
+          </a:ln>
+          <a:extLst>
+            <a:ext uri="{909E8E84-426E-40DD-AFC4-6F175D3DCCD1}">
+              <a14:hiddenFill xmlns:a14="http://schemas.microsoft.com/office/drawing/2010/main">
+                <a:solidFill>
+                  <a:schemeClr val="accent1"/>
+                </a:solidFill>
+              </a14:hiddenFill>
+            </a:ext>
+            <a:ext uri="{91240B29-F687-4F45-9708-019B960494DF}">
+              <a14:hiddenLine xmlns:a14="http://schemas.microsoft.com/office/drawing/2010/main" w="9525">
+                <a:solidFill>
+                  <a:schemeClr val="tx1"/>
+                </a:solidFill>
+                <a:miter lim="800000"/>
+                <a:headEnd/>
+                <a:tailEnd/>
+              </a14:hiddenLine>
+            </a:ext>
+          </a:extLst>
+        </p:spPr>
+      </p:pic>
+      <p:sp>
+        <p:nvSpPr>
+          <p:cNvPr id="2" name="1 Título"/>
+          <p:cNvSpPr>
+            <a:spLocks noGrp="1"/>
+          </p:cNvSpPr>
+          <p:nvPr>
+            <p:ph type="title"/>
+          </p:nvPr>
+        </p:nvSpPr>
+        <p:spPr>
+          <a:xfrm>
+            <a:off x="2555776" y="-66607"/>
+            <a:ext cx="5410944" cy="1143000"/>
+          </a:xfrm>
+        </p:spPr>
+        <p:txBody>
+          <a:bodyPr>
+            <a:normAutofit/>
+          </a:bodyPr>
+          <a:lstStyle/>
+          <a:p>
+            <a:r>
+              <a:rPr lang="es-ES" sz="3200" b="1" dirty="0">
+                <a:solidFill>
+                  <a:schemeClr val="bg1"/>
+                </a:solidFill>
+              </a:rPr>
+              <a:t>Interfaces Del Sistema</a:t>
+            </a:r>
+            <a:endParaRPr lang="es-ES" sz="3200" dirty="0">
+              <a:solidFill>
+                <a:schemeClr val="bg1"/>
+              </a:solidFill>
+            </a:endParaRPr>
+          </a:p>
+        </p:txBody>
+      </p:sp>
+      <p:pic>
+        <p:nvPicPr>
+          <p:cNvPr id="6" name="Imagen 5"/>
+          <p:cNvPicPr>
+            <a:picLocks noChangeAspect="1"/>
+          </p:cNvPicPr>
+          <p:nvPr/>
+        </p:nvPicPr>
+        <p:blipFill rotWithShape="1">
+          <a:blip r:embed="rId3" cstate="print">
+            <a:extLst>
+              <a:ext uri="{28A0092B-C50C-407E-A947-70E740481C1C}">
+                <a14:useLocalDpi xmlns:a14="http://schemas.microsoft.com/office/drawing/2010/main" val="0"/>
+              </a:ext>
+            </a:extLst>
+          </a:blip>
+          <a:srcRect l="4235" t="5471" r="70358" b="63070"/>
+          <a:stretch/>
+        </p:blipFill>
+        <p:spPr>
+          <a:xfrm>
+            <a:off x="303249" y="0"/>
+            <a:ext cx="921475" cy="883080"/>
+          </a:xfrm>
+          <a:prstGeom prst="rect">
+            <a:avLst/>
+          </a:prstGeom>
+        </p:spPr>
+      </p:pic>
+      <p:sp>
+        <p:nvSpPr>
+          <p:cNvPr id="4" name="Marcador de número de diapositiva 3"/>
+          <p:cNvSpPr>
+            <a:spLocks noGrp="1"/>
+          </p:cNvSpPr>
+          <p:nvPr>
+            <p:ph type="sldNum" sz="quarter" idx="12"/>
+          </p:nvPr>
+        </p:nvSpPr>
+        <p:spPr/>
+        <p:txBody>
+          <a:bodyPr/>
+          <a:lstStyle/>
+          <a:p>
+            <a:fld id="{132FADFE-3B8F-471C-ABF0-DBC7717ECBBC}" type="slidenum">
+              <a:rPr lang="es-ES" smtClean="0"/>
+              <a:t>26</a:t>
+            </a:fld>
+            <a:endParaRPr lang="es-ES"/>
+          </a:p>
+        </p:txBody>
+      </p:sp>
+      <p:pic>
+        <p:nvPicPr>
+          <p:cNvPr id="5" name="Imagen 4" descr="Captura de pantalla de un celular&#10;&#10;El contenido generado por IA puede ser incorrecto.">
+            <a:extLst>
+              <a:ext uri="{FF2B5EF4-FFF2-40B4-BE49-F238E27FC236}">
+                <a16:creationId xmlns:a16="http://schemas.microsoft.com/office/drawing/2014/main" id="{CA8A267A-2666-E415-9FA5-487C5C95906C}"/>
+              </a:ext>
+            </a:extLst>
+          </p:cNvPr>
+          <p:cNvPicPr>
+            <a:picLocks noChangeAspect="1"/>
+          </p:cNvPicPr>
+          <p:nvPr/>
+        </p:nvPicPr>
+        <p:blipFill>
+          <a:blip r:embed="rId4">
+            <a:extLst>
+              <a:ext uri="{28A0092B-C50C-407E-A947-70E740481C1C}">
+                <a14:useLocalDpi xmlns:a14="http://schemas.microsoft.com/office/drawing/2010/main" val="0"/>
+              </a:ext>
+            </a:extLst>
+          </a:blip>
+          <a:stretch>
+            <a:fillRect/>
+          </a:stretch>
+        </p:blipFill>
+        <p:spPr>
+          <a:xfrm>
+            <a:off x="0" y="1659828"/>
+            <a:ext cx="9144000" cy="4568140"/>
+          </a:xfrm>
+          <a:prstGeom prst="rect">
+            <a:avLst/>
+          </a:prstGeom>
+        </p:spPr>
+      </p:pic>
+    </p:spTree>
+    <p:extLst>
+      <p:ext uri="{BB962C8B-B14F-4D97-AF65-F5344CB8AC3E}">
+        <p14:creationId xmlns:p14="http://schemas.microsoft.com/office/powerpoint/2010/main" val="669480691"/>
       </p:ext>
     </p:extLst>
   </p:cSld>
@@ -12029,6 +12173,17 @@
               </a:spcAft>
             </a:pPr>
             <a:r>
+              <a:rPr lang="es-CU" sz="2400" dirty="0">
+                <a:solidFill>
+                  <a:srgbClr val="000000"/>
+                </a:solidFill>
+                <a:effectLst/>
+                <a:latin typeface="Arial" panose="020B0604020202020204" pitchFamily="34" charset="0"/>
+                <a:ea typeface="Arial" panose="020B0604020202020204" pitchFamily="34" charset="0"/>
+              </a:rPr>
+              <a:t>Ocurrencia de errores en la recogida de la </a:t>
+            </a:r>
+            <a:r>
               <a:rPr lang="es-ES" sz="2400" dirty="0">
                 <a:solidFill>
                   <a:srgbClr val="000000"/>
@@ -12037,7 +12192,7 @@
                 <a:latin typeface="Arial" panose="020B0604020202020204" pitchFamily="34" charset="0"/>
                 <a:ea typeface="Calibri" panose="020F0502020204030204" pitchFamily="34" charset="0"/>
               </a:rPr>
-              <a:t>Insuficiente control en la gestión de la información referente al cálculo del transporte de sedimentos en las costas cubanas de la región sur-oriental para garantizar acciones efectivas que prevengan los efectos de la erosión costera.</a:t>
+              <a:t>información referente al cálculo del transporte de sedimentos en las costas cubanas de la región sur-oriental para garantizar acciones efectivas que prevengan los efectos de la erosión costera.</a:t>
             </a:r>
             <a:endParaRPr lang="es-CU" sz="2400" dirty="0">
               <a:effectLst/>

</xml_diff>